<commit_message>
fix: removed unuses parameters, duplicate ENGAGE rule, model-runner variables, and action definitions
</commit_message>
<xml_diff>
--- a/output/poster/Poster_59.pptx
+++ b/output/poster/Poster_59.pptx
@@ -1242,8 +1242,8 @@
         </p:nvSpPr>
         <p:spPr>
           <a:xfrm>
-            <a:off x="927042" y="3614227"/>
-            <a:ext cx="6000750" cy="1000125"/>
+            <a:off x="927043" y="3614227"/>
+            <a:ext cx="4029006" cy="1000125"/>
           </a:xfrm>
           <a:prstGeom prst="roundRect">
             <a:avLst>
@@ -1418,7 +1418,7 @@
                 <a:ea typeface="Noto Sans"/>
                 <a:cs typeface="Noto Sans"/>
               </a:rPr>
-              <a:t>Changing gaze and distance, and missed detections, make this decision difficult. [1]</a:t>
+              <a:t>Changing gaze and distance, and missed detections, make this decision difficult.</a:t>
             </a:r>
           </a:p>
         </p:txBody>
@@ -1518,7 +1518,7 @@
         <p:spPr>
           <a:xfrm>
             <a:off x="10952292" y="3614227"/>
-            <a:ext cx="6000750" cy="1000125"/>
+            <a:ext cx="3312348" cy="1000125"/>
           </a:xfrm>
           <a:prstGeom prst="roundRect">
             <a:avLst>
@@ -1804,136 +1804,6 @@
       </p:sp>
       <p:sp>
         <p:nvSpPr>
-          <p:cNvPr id="19" name="methods-heading">
-            <a:extLst>
-              <a:ext uri="{FF2B5EF4-FFF2-40B4-BE49-F238E27FC236}">
-                <a16:creationId xmlns:a16="http://schemas.microsoft.com/office/drawing/2014/main" id="{019EB9FE-B8C5-4597-8F66-2EFCEA73FC0E}"/>
-              </a:ext>
-            </a:extLst>
-          </p:cNvPr>
-          <p:cNvSpPr>
-            <a:spLocks noGrp="1"/>
-          </p:cNvSpPr>
-          <p:nvPr/>
-        </p:nvSpPr>
-        <p:spPr>
-          <a:xfrm>
-            <a:off x="977686" y="9551064"/>
-            <a:ext cx="11430000" cy="1000125"/>
-          </a:xfrm>
-          <a:prstGeom prst="rect">
-            <a:avLst/>
-          </a:prstGeom>
-          <a:noFill/>
-          <a:ln w="0">
-            <a:noFill/>
-          </a:ln>
-        </p:spPr>
-        <p:txBody>
-          <a:bodyPr>
-            <a:noAutofit/>
-          </a:bodyPr>
-          <a:lstStyle/>
-          <a:p>
-            <a:pPr algn="l">
-              <a:defRPr sz="6000" b="1">
-                <a:solidFill>
-                  <a:srgbClr val="22577A"/>
-                </a:solidFill>
-                <a:latin typeface="Rubik"/>
-                <a:ea typeface="Rubik"/>
-                <a:cs typeface="Rubik"/>
-              </a:defRPr>
-            </a:pPr>
-            <a:r>
-              <a:rPr lang="en-NZ" sz="5000" b="1" dirty="0">
-                <a:solidFill>
-                  <a:srgbClr val="22577A"/>
-                </a:solidFill>
-                <a:latin typeface="Rubik"/>
-                <a:ea typeface="Rubik"/>
-                <a:cs typeface="Rubik"/>
-              </a:rPr>
-              <a:t>Our Pipeline</a:t>
-            </a:r>
-            <a:endParaRPr sz="5000" b="1" dirty="0">
-              <a:solidFill>
-                <a:srgbClr val="22577A"/>
-              </a:solidFill>
-              <a:latin typeface="Rubik"/>
-              <a:ea typeface="Rubik"/>
-              <a:cs typeface="Rubik"/>
-            </a:endParaRPr>
-          </a:p>
-        </p:txBody>
-      </p:sp>
-      <p:sp>
-        <p:nvSpPr>
-          <p:cNvPr id="36" name="results-heading">
-            <a:extLst>
-              <a:ext uri="{FF2B5EF4-FFF2-40B4-BE49-F238E27FC236}">
-                <a16:creationId xmlns:a16="http://schemas.microsoft.com/office/drawing/2014/main" id="{995E6662-000D-4080-97FD-F5D4EE84DFBF}"/>
-              </a:ext>
-            </a:extLst>
-          </p:cNvPr>
-          <p:cNvSpPr>
-            <a:spLocks noGrp="1"/>
-          </p:cNvSpPr>
-          <p:nvPr/>
-        </p:nvSpPr>
-        <p:spPr>
-          <a:xfrm>
-            <a:off x="917016" y="16311898"/>
-            <a:ext cx="19479000" cy="1047750"/>
-          </a:xfrm>
-          <a:prstGeom prst="rect">
-            <a:avLst/>
-          </a:prstGeom>
-          <a:noFill/>
-          <a:ln w="0">
-            <a:noFill/>
-          </a:ln>
-        </p:spPr>
-        <p:txBody>
-          <a:bodyPr>
-            <a:noAutofit/>
-          </a:bodyPr>
-          <a:lstStyle/>
-          <a:p>
-            <a:pPr algn="l">
-              <a:defRPr sz="6000" b="1">
-                <a:solidFill>
-                  <a:srgbClr val="22577A"/>
-                </a:solidFill>
-                <a:latin typeface="Rubik"/>
-                <a:ea typeface="Rubik"/>
-                <a:cs typeface="Rubik"/>
-              </a:defRPr>
-            </a:pPr>
-            <a:r>
-              <a:rPr lang="en-AU" sz="5000" b="1" dirty="0">
-                <a:solidFill>
-                  <a:srgbClr val="22577A"/>
-                </a:solidFill>
-                <a:latin typeface="Rubik"/>
-                <a:ea typeface="Rubik"/>
-                <a:cs typeface="Rubik"/>
-              </a:rPr>
-              <a:t>Results</a:t>
-            </a:r>
-            <a:endParaRPr sz="5000" b="1" dirty="0">
-              <a:solidFill>
-                <a:srgbClr val="22577A"/>
-              </a:solidFill>
-              <a:latin typeface="Rubik"/>
-              <a:ea typeface="Rubik"/>
-              <a:cs typeface="Rubik"/>
-            </a:endParaRPr>
-          </a:p>
-        </p:txBody>
-      </p:sp>
-      <p:sp>
-        <p:nvSpPr>
           <p:cNvPr id="37" name="results-shadow">
             <a:extLst>
               <a:ext uri="{FF2B5EF4-FFF2-40B4-BE49-F238E27FC236}">
@@ -1948,7 +1818,7 @@
         </p:nvSpPr>
         <p:spPr>
           <a:xfrm>
-            <a:off x="1095375" y="17349109"/>
+            <a:off x="1095375" y="17541642"/>
             <a:ext cx="19479000" cy="7172859"/>
           </a:xfrm>
           <a:prstGeom prst="roundRect">
@@ -1987,7 +1857,7 @@
         </p:nvSpPr>
         <p:spPr>
           <a:xfrm>
-            <a:off x="952500" y="17193072"/>
+            <a:off x="952500" y="17385605"/>
             <a:ext cx="19479000" cy="7153131"/>
           </a:xfrm>
           <a:prstGeom prst="roundRect">
@@ -2026,8 +1896,8 @@
         </p:nvSpPr>
         <p:spPr>
           <a:xfrm>
-            <a:off x="1095375" y="25436557"/>
-            <a:ext cx="19479000" cy="2381250"/>
+            <a:off x="1095375" y="25629090"/>
+            <a:ext cx="19479000" cy="3069230"/>
           </a:xfrm>
           <a:prstGeom prst="roundRect">
             <a:avLst>
@@ -2065,8 +1935,8 @@
         </p:nvSpPr>
         <p:spPr>
           <a:xfrm>
-            <a:off x="952500" y="25284157"/>
-            <a:ext cx="19479000" cy="2381250"/>
+            <a:off x="952500" y="25476690"/>
+            <a:ext cx="19479000" cy="3069230"/>
           </a:xfrm>
           <a:prstGeom prst="roundRect">
             <a:avLst>
@@ -2104,8 +1974,8 @@
         </p:nvSpPr>
         <p:spPr>
           <a:xfrm>
-            <a:off x="952500" y="24760282"/>
-            <a:ext cx="10725150" cy="1000125"/>
+            <a:off x="952500" y="24952815"/>
+            <a:ext cx="7864929" cy="1000125"/>
           </a:xfrm>
           <a:prstGeom prst="roundRect">
             <a:avLst>
@@ -2143,7 +2013,7 @@
         </p:nvSpPr>
         <p:spPr>
           <a:xfrm>
-            <a:off x="1111948" y="24835908"/>
+            <a:off x="1111948" y="25028441"/>
             <a:ext cx="10201275" cy="857250"/>
           </a:xfrm>
           <a:prstGeom prst="rect">
@@ -2217,8 +2087,8 @@
         </p:blipFill>
         <p:spPr>
           <a:xfrm>
-            <a:off x="916304" y="28022706"/>
-            <a:ext cx="2667000" cy="1352415"/>
+            <a:off x="17673572" y="28496233"/>
+            <a:ext cx="2900803" cy="1470975"/>
           </a:xfrm>
           <a:prstGeom prst="rect">
             <a:avLst/>
@@ -2241,7 +2111,7 @@
         </p:nvSpPr>
         <p:spPr>
           <a:xfrm>
-            <a:off x="3603819" y="28223708"/>
+            <a:off x="977686" y="28707845"/>
             <a:ext cx="8096250" cy="523875"/>
           </a:xfrm>
           <a:prstGeom prst="rect">
@@ -2268,6 +2138,17 @@
                 <a:cs typeface="Rubik"/>
               </a:defRPr>
             </a:pPr>
+            <a:r>
+              <a:rPr lang="en-AU" sz="2600" b="1" dirty="0">
+                <a:solidFill>
+                  <a:srgbClr val="26333C"/>
+                </a:solidFill>
+                <a:latin typeface="Rubik"/>
+                <a:ea typeface="Rubik"/>
+                <a:cs typeface="Rubik"/>
+              </a:rPr>
+              <a:t>By </a:t>
+            </a:r>
             <a:r>
               <a:rPr sz="2600" b="1" dirty="0">
                 <a:solidFill>
@@ -2298,7 +2179,7 @@
         </p:nvSpPr>
         <p:spPr>
           <a:xfrm>
-            <a:off x="3583304" y="28643389"/>
+            <a:off x="957171" y="29127526"/>
             <a:ext cx="8286750" cy="731732"/>
           </a:xfrm>
           <a:prstGeom prst="rect">
@@ -2413,200 +2294,6 @@
               <a:ea typeface="Noto Sans"/>
               <a:cs typeface="Noto Sans"/>
             </a:endParaRPr>
-          </a:p>
-        </p:txBody>
-      </p:sp>
-      <p:sp>
-        <p:nvSpPr>
-          <p:cNvPr id="69" name="department">
-            <a:extLst>
-              <a:ext uri="{FF2B5EF4-FFF2-40B4-BE49-F238E27FC236}">
-                <a16:creationId xmlns:a16="http://schemas.microsoft.com/office/drawing/2014/main" id="{926DA717-5D16-46B8-8BF0-61E61562367D}"/>
-              </a:ext>
-            </a:extLst>
-          </p:cNvPr>
-          <p:cNvSpPr>
-            <a:spLocks noGrp="1"/>
-          </p:cNvSpPr>
-          <p:nvPr/>
-        </p:nvSpPr>
-        <p:spPr>
-          <a:xfrm>
-            <a:off x="16621125" y="28320992"/>
-            <a:ext cx="7191375" cy="866775"/>
-          </a:xfrm>
-          <a:prstGeom prst="rect">
-            <a:avLst/>
-          </a:prstGeom>
-          <a:noFill/>
-          <a:ln w="0">
-            <a:noFill/>
-          </a:ln>
-        </p:spPr>
-        <p:txBody>
-          <a:bodyPr>
-            <a:noAutofit/>
-          </a:bodyPr>
-          <a:lstStyle/>
-          <a:p>
-            <a:pPr algn="l">
-              <a:defRPr sz="2400" b="1">
-                <a:solidFill>
-                  <a:srgbClr val="22577A"/>
-                </a:solidFill>
-                <a:latin typeface="Noto Sans"/>
-                <a:ea typeface="Noto Sans"/>
-                <a:cs typeface="Noto Sans"/>
-              </a:defRPr>
-            </a:pPr>
-            <a:r>
-              <a:rPr sz="2400" b="1" dirty="0">
-                <a:solidFill>
-                  <a:srgbClr val="22577A"/>
-                </a:solidFill>
-                <a:latin typeface="Noto Sans"/>
-                <a:ea typeface="Noto Sans"/>
-                <a:cs typeface="Noto Sans"/>
-              </a:rPr>
-              <a:t>Electrical, Computer and</a:t>
-            </a:r>
-          </a:p>
-          <a:p>
-            <a:pPr algn="l">
-              <a:defRPr sz="2400" b="1">
-                <a:solidFill>
-                  <a:srgbClr val="22577A"/>
-                </a:solidFill>
-                <a:latin typeface="Noto Sans"/>
-                <a:ea typeface="Noto Sans"/>
-                <a:cs typeface="Noto Sans"/>
-              </a:defRPr>
-            </a:pPr>
-            <a:r>
-              <a:rPr sz="2400" b="1" dirty="0">
-                <a:solidFill>
-                  <a:srgbClr val="22577A"/>
-                </a:solidFill>
-                <a:latin typeface="Noto Sans"/>
-                <a:ea typeface="Noto Sans"/>
-                <a:cs typeface="Noto Sans"/>
-              </a:rPr>
-              <a:t>Software Engineering</a:t>
-            </a:r>
-          </a:p>
-        </p:txBody>
-      </p:sp>
-      <p:sp>
-        <p:nvSpPr>
-          <p:cNvPr id="70" name="department-logo">
-            <a:extLst>
-              <a:ext uri="{FF2B5EF4-FFF2-40B4-BE49-F238E27FC236}">
-                <a16:creationId xmlns:a16="http://schemas.microsoft.com/office/drawing/2014/main" id="{DCAD0185-6132-483C-A18C-B672C5397712}"/>
-              </a:ext>
-            </a:extLst>
-          </p:cNvPr>
-          <p:cNvSpPr>
-            <a:spLocks noGrp="1"/>
-          </p:cNvSpPr>
-          <p:nvPr/>
-        </p:nvSpPr>
-        <p:spPr>
-          <a:xfrm>
-            <a:off x="16569994" y="29151717"/>
-            <a:ext cx="7191375" cy="457200"/>
-          </a:xfrm>
-          <a:prstGeom prst="rect">
-            <a:avLst/>
-          </a:prstGeom>
-          <a:noFill/>
-          <a:ln w="0">
-            <a:noFill/>
-          </a:ln>
-        </p:spPr>
-        <p:txBody>
-          <a:bodyPr>
-            <a:noAutofit/>
-          </a:bodyPr>
-          <a:lstStyle/>
-          <a:p>
-            <a:pPr algn="l">
-              <a:defRPr sz="2100" b="0">
-                <a:solidFill>
-                  <a:srgbClr val="22577A"/>
-                </a:solidFill>
-                <a:latin typeface="Noto Sans"/>
-                <a:ea typeface="Noto Sans"/>
-                <a:cs typeface="Noto Sans"/>
-              </a:defRPr>
-            </a:pPr>
-            <a:r>
-              <a:rPr sz="2100" b="0" dirty="0">
-                <a:solidFill>
-                  <a:srgbClr val="22577A"/>
-                </a:solidFill>
-                <a:latin typeface="Noto Sans"/>
-                <a:ea typeface="Noto Sans"/>
-                <a:cs typeface="Noto Sans"/>
-              </a:rPr>
-              <a:t>[Official department logo to add]</a:t>
-            </a:r>
-          </a:p>
-        </p:txBody>
-      </p:sp>
-      <p:sp>
-        <p:nvSpPr>
-          <p:cNvPr id="71" name="references">
-            <a:extLst>
-              <a:ext uri="{FF2B5EF4-FFF2-40B4-BE49-F238E27FC236}">
-                <a16:creationId xmlns:a16="http://schemas.microsoft.com/office/drawing/2014/main" id="{B58270A2-941B-41F5-BB36-00EDE2A7CE1B}"/>
-              </a:ext>
-            </a:extLst>
-          </p:cNvPr>
-          <p:cNvSpPr>
-            <a:spLocks noGrp="1"/>
-          </p:cNvSpPr>
-          <p:nvPr/>
-        </p:nvSpPr>
-        <p:spPr>
-          <a:xfrm>
-            <a:off x="851883" y="29414370"/>
-            <a:ext cx="19479000" cy="276225"/>
-          </a:xfrm>
-          <a:prstGeom prst="rect">
-            <a:avLst/>
-          </a:prstGeom>
-          <a:noFill/>
-          <a:ln w="0">
-            <a:noFill/>
-          </a:ln>
-        </p:spPr>
-        <p:txBody>
-          <a:bodyPr>
-            <a:noAutofit/>
-          </a:bodyPr>
-          <a:lstStyle/>
-          <a:p>
-            <a:pPr algn="l">
-              <a:defRPr sz="1800" b="0">
-                <a:solidFill>
-                  <a:srgbClr val="26333C"/>
-                </a:solidFill>
-                <a:latin typeface="Noto Sans"/>
-                <a:ea typeface="Noto Sans"/>
-                <a:cs typeface="Noto Sans"/>
-              </a:defRPr>
-            </a:pPr>
-            <a:r>
-              <a:rPr sz="1800" b="0" dirty="0">
-                <a:solidFill>
-                  <a:srgbClr val="26333C"/>
-                </a:solidFill>
-                <a:latin typeface="Noto Sans"/>
-                <a:ea typeface="Noto Sans"/>
-                <a:cs typeface="Noto Sans"/>
-              </a:rPr>
-              <a:t>[1] Project 59 development replay. [2] Initial survey (37 responses). Photo: navel robotics. Thanks to our survey participants.</a:t>
-            </a:r>
           </a:p>
         </p:txBody>
       </p:sp>
@@ -2874,7 +2561,7 @@
         </p:nvSpPr>
         <p:spPr>
           <a:xfrm>
-            <a:off x="16195568" y="10499210"/>
+            <a:off x="16204855" y="10759143"/>
             <a:ext cx="4405406" cy="1795466"/>
           </a:xfrm>
           <a:prstGeom prst="roundRect">
@@ -2913,7 +2600,7 @@
         </p:nvSpPr>
         <p:spPr>
           <a:xfrm>
-            <a:off x="11155522" y="10504971"/>
+            <a:off x="11164809" y="10764904"/>
             <a:ext cx="4405406" cy="1795466"/>
           </a:xfrm>
           <a:prstGeom prst="roundRect">
@@ -2952,7 +2639,7 @@
         </p:nvSpPr>
         <p:spPr>
           <a:xfrm>
-            <a:off x="6133735" y="10510732"/>
+            <a:off x="6143022" y="10770665"/>
             <a:ext cx="4405406" cy="1795466"/>
           </a:xfrm>
           <a:prstGeom prst="roundRect">
@@ -2991,7 +2678,7 @@
         </p:nvSpPr>
         <p:spPr>
           <a:xfrm>
-            <a:off x="1111948" y="10516671"/>
+            <a:off x="1121235" y="10776604"/>
             <a:ext cx="4405406" cy="1795466"/>
           </a:xfrm>
           <a:prstGeom prst="roundRect">
@@ -3030,7 +2717,7 @@
         </p:nvSpPr>
         <p:spPr>
           <a:xfrm>
-            <a:off x="988123" y="10421422"/>
+            <a:off x="997410" y="10681355"/>
             <a:ext cx="4405406" cy="1765544"/>
           </a:xfrm>
           <a:prstGeom prst="roundRect">
@@ -3069,7 +2756,7 @@
         </p:nvSpPr>
         <p:spPr>
           <a:xfrm>
-            <a:off x="1233488" y="10499557"/>
+            <a:off x="1242775" y="10759490"/>
             <a:ext cx="3986306" cy="545714"/>
           </a:xfrm>
           <a:prstGeom prst="rect">
@@ -3156,7 +2843,7 @@
         </p:nvSpPr>
         <p:spPr>
           <a:xfrm>
-            <a:off x="6012654" y="10421422"/>
+            <a:off x="6021941" y="10681355"/>
             <a:ext cx="4405406" cy="1765544"/>
           </a:xfrm>
           <a:prstGeom prst="roundRect">
@@ -3195,7 +2882,7 @@
         </p:nvSpPr>
         <p:spPr>
           <a:xfrm>
-            <a:off x="6221175" y="10517494"/>
+            <a:off x="6230462" y="10777427"/>
             <a:ext cx="3986306" cy="545714"/>
           </a:xfrm>
           <a:prstGeom prst="rect">
@@ -3282,7 +2969,7 @@
         </p:nvSpPr>
         <p:spPr>
           <a:xfrm>
-            <a:off x="11037186" y="10421422"/>
+            <a:off x="11046473" y="10681355"/>
             <a:ext cx="4405406" cy="1765544"/>
           </a:xfrm>
           <a:prstGeom prst="roundRect">
@@ -3321,7 +3008,7 @@
         </p:nvSpPr>
         <p:spPr>
           <a:xfrm>
-            <a:off x="11245707" y="10517494"/>
+            <a:off x="11254994" y="10777427"/>
             <a:ext cx="3986306" cy="545714"/>
           </a:xfrm>
           <a:prstGeom prst="rect">
@@ -3419,7 +3106,7 @@
         </p:nvSpPr>
         <p:spPr>
           <a:xfrm>
-            <a:off x="11222740" y="11065848"/>
+            <a:off x="11232027" y="11325781"/>
             <a:ext cx="4024406" cy="963024"/>
           </a:xfrm>
           <a:prstGeom prst="rect">
@@ -3498,7 +3185,7 @@
         </p:nvSpPr>
         <p:spPr>
           <a:xfrm>
-            <a:off x="16061717" y="10421422"/>
+            <a:off x="16071004" y="10681355"/>
             <a:ext cx="4405406" cy="1765544"/>
           </a:xfrm>
           <a:prstGeom prst="roundRect">
@@ -3537,7 +3224,7 @@
         </p:nvSpPr>
         <p:spPr>
           <a:xfrm>
-            <a:off x="16194919" y="10517494"/>
+            <a:off x="16204206" y="10777427"/>
             <a:ext cx="3986306" cy="545714"/>
           </a:xfrm>
           <a:prstGeom prst="rect">
@@ -3602,7 +3289,7 @@
         </p:nvSpPr>
         <p:spPr>
           <a:xfrm>
-            <a:off x="16247271" y="11099186"/>
+            <a:off x="16256558" y="11359119"/>
             <a:ext cx="4024406" cy="963024"/>
           </a:xfrm>
           <a:prstGeom prst="rect">
@@ -3668,7 +3355,7 @@
         </p:nvCxnSpPr>
         <p:spPr>
           <a:xfrm>
-            <a:off x="5393529" y="11304194"/>
+            <a:off x="5402816" y="11564127"/>
             <a:ext cx="619125" cy="0"/>
           </a:xfrm>
           <a:prstGeom prst="straightConnector1">
@@ -3699,7 +3386,7 @@
         </p:nvCxnSpPr>
         <p:spPr>
           <a:xfrm>
-            <a:off x="10418060" y="11304194"/>
+            <a:off x="10427347" y="11564127"/>
             <a:ext cx="619126" cy="0"/>
           </a:xfrm>
           <a:prstGeom prst="straightConnector1">
@@ -3730,7 +3417,7 @@
         </p:nvCxnSpPr>
         <p:spPr>
           <a:xfrm>
-            <a:off x="15442592" y="11304194"/>
+            <a:off x="15451879" y="11564127"/>
             <a:ext cx="619125" cy="0"/>
           </a:xfrm>
           <a:prstGeom prst="straightConnector1">
@@ -3760,7 +3447,7 @@
         </p:nvSpPr>
         <p:spPr>
           <a:xfrm>
-            <a:off x="1233488" y="11188146"/>
+            <a:off x="1242775" y="11448079"/>
             <a:ext cx="3968512" cy="919788"/>
           </a:xfrm>
           <a:prstGeom prst="rect">
@@ -3825,7 +3512,7 @@
         </p:nvSpPr>
         <p:spPr>
           <a:xfrm>
-            <a:off x="6422394" y="11086540"/>
+            <a:off x="6431681" y="11346473"/>
             <a:ext cx="3588804" cy="919788"/>
           </a:xfrm>
           <a:prstGeom prst="rect">
@@ -3888,7 +3575,7 @@
         </p:nvGrpSpPr>
         <p:grpSpPr>
           <a:xfrm>
-            <a:off x="973169" y="13194220"/>
+            <a:off x="982456" y="13454153"/>
             <a:ext cx="4524375" cy="3095625"/>
             <a:chOff x="973169" y="13194220"/>
             <a:chExt cx="4524375" cy="3095625"/>
@@ -4734,7 +4421,7 @@
         </p:nvGrpSpPr>
         <p:grpSpPr>
           <a:xfrm>
-            <a:off x="5997702" y="13194220"/>
+            <a:off x="6006989" y="13454153"/>
             <a:ext cx="4524375" cy="3095625"/>
             <a:chOff x="5997702" y="13194220"/>
             <a:chExt cx="4524375" cy="3095625"/>
@@ -5639,7 +5326,7 @@
         </p:nvGrpSpPr>
         <p:grpSpPr>
           <a:xfrm>
-            <a:off x="11022235" y="13194220"/>
+            <a:off x="11031522" y="13454153"/>
             <a:ext cx="4524375" cy="3095625"/>
             <a:chOff x="11022235" y="13194220"/>
             <a:chExt cx="4524375" cy="3095625"/>
@@ -6433,7 +6120,7 @@
         </p:nvGrpSpPr>
         <p:grpSpPr>
           <a:xfrm>
-            <a:off x="16046768" y="13194220"/>
+            <a:off x="16056055" y="13454153"/>
             <a:ext cx="4524375" cy="3095625"/>
             <a:chOff x="16046768" y="13194220"/>
             <a:chExt cx="4524375" cy="3095625"/>
@@ -7229,7 +6916,7 @@
         </p:nvSpPr>
         <p:spPr>
           <a:xfrm>
-            <a:off x="18259520" y="12249150"/>
+            <a:off x="18268807" y="12509083"/>
             <a:ext cx="9525" cy="552450"/>
           </a:xfrm>
           <a:custGeom>
@@ -7281,7 +6968,7 @@
         </p:nvSpPr>
         <p:spPr>
           <a:xfrm>
-            <a:off x="3175873" y="12801600"/>
+            <a:off x="3185160" y="13061533"/>
             <a:ext cx="15073598" cy="9525"/>
           </a:xfrm>
           <a:custGeom>
@@ -7333,7 +7020,7 @@
         </p:nvSpPr>
         <p:spPr>
           <a:xfrm>
-            <a:off x="3175873" y="12801600"/>
+            <a:off x="3185160" y="13061533"/>
             <a:ext cx="9525" cy="276225"/>
           </a:xfrm>
           <a:custGeom>
@@ -7385,7 +7072,7 @@
         </p:nvSpPr>
         <p:spPr>
           <a:xfrm>
-            <a:off x="3137772" y="13054124"/>
+            <a:off x="3147059" y="13314057"/>
             <a:ext cx="76200" cy="133350"/>
           </a:xfrm>
           <a:prstGeom prst="downArrow">
@@ -7422,7 +7109,7 @@
         </p:nvSpPr>
         <p:spPr>
           <a:xfrm>
-            <a:off x="8200406" y="12801600"/>
+            <a:off x="8209693" y="13061533"/>
             <a:ext cx="9525" cy="276225"/>
           </a:xfrm>
           <a:custGeom>
@@ -7474,7 +7161,7 @@
         </p:nvSpPr>
         <p:spPr>
           <a:xfrm>
-            <a:off x="8162305" y="13057324"/>
+            <a:off x="8171592" y="13317257"/>
             <a:ext cx="76200" cy="133350"/>
           </a:xfrm>
           <a:prstGeom prst="downArrow">
@@ -7511,7 +7198,7 @@
         </p:nvSpPr>
         <p:spPr>
           <a:xfrm>
-            <a:off x="13224939" y="12801600"/>
+            <a:off x="13234226" y="13061533"/>
             <a:ext cx="9525" cy="276225"/>
           </a:xfrm>
           <a:custGeom>
@@ -7563,7 +7250,7 @@
         </p:nvSpPr>
         <p:spPr>
           <a:xfrm>
-            <a:off x="13186838" y="13039725"/>
+            <a:off x="13196125" y="13299658"/>
             <a:ext cx="76200" cy="133350"/>
           </a:xfrm>
           <a:prstGeom prst="downArrow">
@@ -7600,7 +7287,7 @@
         </p:nvSpPr>
         <p:spPr>
           <a:xfrm>
-            <a:off x="18258995" y="12797861"/>
+            <a:off x="18268282" y="13057794"/>
             <a:ext cx="9525" cy="276225"/>
           </a:xfrm>
           <a:custGeom>
@@ -7652,7 +7339,7 @@
         </p:nvSpPr>
         <p:spPr>
           <a:xfrm>
-            <a:off x="18223145" y="13047252"/>
+            <a:off x="18232432" y="13307185"/>
             <a:ext cx="71700" cy="135347"/>
           </a:xfrm>
           <a:prstGeom prst="downArrow">
@@ -7689,7 +7376,7 @@
         </p:nvSpPr>
         <p:spPr>
           <a:xfrm>
-            <a:off x="9312951" y="12421468"/>
+            <a:off x="9322238" y="12681401"/>
             <a:ext cx="2914380" cy="356171"/>
           </a:xfrm>
           <a:prstGeom prst="rect">
@@ -7727,6 +7414,226 @@
               </a:rPr>
               <a:t>Four possible actions</a:t>
             </a:r>
+          </a:p>
+        </p:txBody>
+      </p:sp>
+      <p:sp>
+        <p:nvSpPr>
+          <p:cNvPr id="463" name="background-tab">
+            <a:extLst>
+              <a:ext uri="{FF2B5EF4-FFF2-40B4-BE49-F238E27FC236}">
+                <a16:creationId xmlns:a16="http://schemas.microsoft.com/office/drawing/2014/main" id="{EB3E78D4-85CC-434C-1D77-6B9A0544F480}"/>
+              </a:ext>
+            </a:extLst>
+          </p:cNvPr>
+          <p:cNvSpPr>
+            <a:spLocks noGrp="1"/>
+          </p:cNvSpPr>
+          <p:nvPr/>
+        </p:nvSpPr>
+        <p:spPr>
+          <a:xfrm>
+            <a:off x="997410" y="9675670"/>
+            <a:ext cx="2616937" cy="929485"/>
+          </a:xfrm>
+          <a:prstGeom prst="roundRect">
+            <a:avLst>
+              <a:gd name="adj" fmla="val 7619"/>
+            </a:avLst>
+          </a:prstGeom>
+          <a:solidFill>
+            <a:srgbClr val="22577A"/>
+          </a:solidFill>
+          <a:ln w="0">
+            <a:noFill/>
+          </a:ln>
+        </p:spPr>
+        <p:txBody>
+          <a:bodyPr/>
+          <a:lstStyle/>
+          <a:p>
+            <a:endParaRPr lang="en-US"/>
+          </a:p>
+        </p:txBody>
+      </p:sp>
+      <p:sp>
+        <p:nvSpPr>
+          <p:cNvPr id="464" name="background-heading">
+            <a:extLst>
+              <a:ext uri="{FF2B5EF4-FFF2-40B4-BE49-F238E27FC236}">
+                <a16:creationId xmlns:a16="http://schemas.microsoft.com/office/drawing/2014/main" id="{9C2DA47E-42E9-3BF2-7458-A79A7359195B}"/>
+              </a:ext>
+            </a:extLst>
+          </p:cNvPr>
+          <p:cNvSpPr>
+            <a:spLocks noGrp="1"/>
+          </p:cNvSpPr>
+          <p:nvPr/>
+        </p:nvSpPr>
+        <p:spPr>
+          <a:xfrm>
+            <a:off x="1099003" y="9717498"/>
+            <a:ext cx="4879618" cy="796701"/>
+          </a:xfrm>
+          <a:prstGeom prst="rect">
+            <a:avLst/>
+          </a:prstGeom>
+          <a:noFill/>
+          <a:ln w="0">
+            <a:noFill/>
+          </a:ln>
+        </p:spPr>
+        <p:txBody>
+          <a:bodyPr>
+            <a:noAutofit/>
+          </a:bodyPr>
+          <a:lstStyle/>
+          <a:p>
+            <a:pPr algn="l">
+              <a:defRPr sz="6000" b="1">
+                <a:solidFill>
+                  <a:srgbClr val="FFFFFF"/>
+                </a:solidFill>
+                <a:latin typeface="Rubik"/>
+                <a:ea typeface="Rubik"/>
+                <a:cs typeface="Rubik"/>
+              </a:defRPr>
+            </a:pPr>
+            <a:r>
+              <a:rPr lang="en-AU" sz="5000" b="1" dirty="0">
+                <a:solidFill>
+                  <a:srgbClr val="FFFFFF"/>
+                </a:solidFill>
+                <a:latin typeface="Rubik"/>
+                <a:ea typeface="Rubik"/>
+                <a:cs typeface="Rubik"/>
+              </a:rPr>
+              <a:t>Pipeline</a:t>
+            </a:r>
+          </a:p>
+          <a:p>
+            <a:pPr algn="l">
+              <a:defRPr sz="6000" b="1">
+                <a:solidFill>
+                  <a:srgbClr val="FFFFFF"/>
+                </a:solidFill>
+                <a:latin typeface="Rubik"/>
+                <a:ea typeface="Rubik"/>
+                <a:cs typeface="Rubik"/>
+              </a:defRPr>
+            </a:pPr>
+            <a:endParaRPr sz="5000" b="1" dirty="0">
+              <a:solidFill>
+                <a:srgbClr val="FFFFFF"/>
+              </a:solidFill>
+              <a:latin typeface="Rubik"/>
+              <a:ea typeface="Rubik"/>
+              <a:cs typeface="Rubik"/>
+            </a:endParaRPr>
+          </a:p>
+        </p:txBody>
+      </p:sp>
+      <p:sp>
+        <p:nvSpPr>
+          <p:cNvPr id="465" name="background-tab">
+            <a:extLst>
+              <a:ext uri="{FF2B5EF4-FFF2-40B4-BE49-F238E27FC236}">
+                <a16:creationId xmlns:a16="http://schemas.microsoft.com/office/drawing/2014/main" id="{98F3330C-770A-9531-3462-2A3253E84D5F}"/>
+              </a:ext>
+            </a:extLst>
+          </p:cNvPr>
+          <p:cNvSpPr>
+            <a:spLocks noGrp="1"/>
+          </p:cNvSpPr>
+          <p:nvPr/>
+        </p:nvSpPr>
+        <p:spPr>
+          <a:xfrm>
+            <a:off x="952125" y="16682414"/>
+            <a:ext cx="2271134" cy="929485"/>
+          </a:xfrm>
+          <a:prstGeom prst="roundRect">
+            <a:avLst>
+              <a:gd name="adj" fmla="val 7619"/>
+            </a:avLst>
+          </a:prstGeom>
+          <a:solidFill>
+            <a:srgbClr val="22577A"/>
+          </a:solidFill>
+          <a:ln w="0">
+            <a:noFill/>
+          </a:ln>
+        </p:spPr>
+        <p:txBody>
+          <a:bodyPr/>
+          <a:lstStyle/>
+          <a:p>
+            <a:endParaRPr lang="en-US"/>
+          </a:p>
+        </p:txBody>
+      </p:sp>
+      <p:sp>
+        <p:nvSpPr>
+          <p:cNvPr id="466" name="background-heading">
+            <a:extLst>
+              <a:ext uri="{FF2B5EF4-FFF2-40B4-BE49-F238E27FC236}">
+                <a16:creationId xmlns:a16="http://schemas.microsoft.com/office/drawing/2014/main" id="{A6812C64-0A4F-2DED-29AA-9AF0257403FC}"/>
+              </a:ext>
+            </a:extLst>
+          </p:cNvPr>
+          <p:cNvSpPr>
+            <a:spLocks noGrp="1"/>
+          </p:cNvSpPr>
+          <p:nvPr/>
+        </p:nvSpPr>
+        <p:spPr>
+          <a:xfrm>
+            <a:off x="1048565" y="16691103"/>
+            <a:ext cx="4879618" cy="796701"/>
+          </a:xfrm>
+          <a:prstGeom prst="rect">
+            <a:avLst/>
+          </a:prstGeom>
+          <a:noFill/>
+          <a:ln w="0">
+            <a:noFill/>
+          </a:ln>
+        </p:spPr>
+        <p:txBody>
+          <a:bodyPr>
+            <a:noAutofit/>
+          </a:bodyPr>
+          <a:lstStyle/>
+          <a:p>
+            <a:pPr algn="l">
+              <a:defRPr sz="6000" b="1">
+                <a:solidFill>
+                  <a:srgbClr val="FFFFFF"/>
+                </a:solidFill>
+                <a:latin typeface="Rubik"/>
+                <a:ea typeface="Rubik"/>
+                <a:cs typeface="Rubik"/>
+              </a:defRPr>
+            </a:pPr>
+            <a:r>
+              <a:rPr lang="en-AU" sz="5000" b="1" dirty="0">
+                <a:solidFill>
+                  <a:srgbClr val="FFFFFF"/>
+                </a:solidFill>
+                <a:latin typeface="Rubik"/>
+                <a:ea typeface="Rubik"/>
+                <a:cs typeface="Rubik"/>
+              </a:rPr>
+              <a:t>Results</a:t>
+            </a:r>
+            <a:endParaRPr sz="5000" b="1" dirty="0">
+              <a:solidFill>
+                <a:srgbClr val="FFFFFF"/>
+              </a:solidFill>
+              <a:latin typeface="Rubik"/>
+              <a:ea typeface="Rubik"/>
+              <a:cs typeface="Rubik"/>
+            </a:endParaRPr>
           </a:p>
         </p:txBody>
       </p:sp>

</xml_diff>

<commit_message>
eval: froze pipeline for evaluation and refinement
</commit_message>
<xml_diff>
--- a/output/poster/Poster_59.pptx
+++ b/output/poster/Poster_59.pptx
@@ -108,6 +108,250 @@
     </a:lvl9pPr>
   </p:defaultTextStyle>
 </p:presentation>
+</file>
+
+<file path=ppt/charts/chart1.xml><?xml version="1.0" encoding="utf-8"?>
+<c:chartSpace xmlns:c="http://schemas.openxmlformats.org/drawingml/2006/chart" xmlns:a="http://schemas.openxmlformats.org/drawingml/2006/main" xmlns:r="http://schemas.openxmlformats.org/officeDocument/2006/relationships" xmlns:c16r2="http://schemas.microsoft.com/office/drawing/2015/06/chart">
+  <c:date1904 val="0"/>
+  <c:lang val="en-GB"/>
+  <c:roundedCorners val="1"/>
+  <mc:AlternateContent xmlns:mc="http://schemas.openxmlformats.org/markup-compatibility/2006">
+    <mc:Choice xmlns:c14="http://schemas.microsoft.com/office/drawing/2007/8/2/chart" Requires="c14">
+      <c14:style val="102"/>
+    </mc:Choice>
+    <mc:Fallback>
+      <c:style val="2"/>
+    </mc:Fallback>
+  </mc:AlternateContent>
+  <c:chart>
+    <c:title>
+      <c:tx>
+        <c:rich>
+          <a:bodyPr/>
+          <a:lstStyle/>
+          <a:p>
+            <a:r>
+              <a:rPr lang="en-NZ" sz="2625" b="1">
+                <a:solidFill>
+                  <a:srgbClr val="22577A"/>
+                </a:solidFill>
+                <a:latin typeface="Noto Sans"/>
+                <a:ea typeface="Noto Sans"/>
+                <a:cs typeface="Noto Sans"/>
+              </a:rPr>
+              <a:t>Mean decision latency (s)</a:t>
+            </a:r>
+          </a:p>
+        </c:rich>
+      </c:tx>
+      <c:overlay val="0"/>
+    </c:title>
+    <c:autoTitleDeleted val="0"/>
+    <c:plotArea>
+      <c:layout/>
+      <c:barChart>
+        <c:barDir val="col"/>
+        <c:grouping val="clustered"/>
+        <c:varyColors val="0"/>
+        <c:ser>
+          <c:idx val="0"/>
+          <c:order val="0"/>
+          <c:tx>
+            <c:v>Mean decision latency (s)</c:v>
+          </c:tx>
+          <c:spPr>
+            <a:solidFill>
+              <a:srgbClr val="22577A"/>
+            </a:solidFill>
+          </c:spPr>
+          <c:invertIfNegative val="1"/>
+          <c:dPt>
+            <c:idx val="0"/>
+            <c:invertIfNegative val="0"/>
+            <c:bubble3D val="0"/>
+            <c:extLst>
+              <c:ext xmlns:c16="http://schemas.microsoft.com/office/drawing/2014/chart" uri="{C3380CC4-5D6E-409C-BE32-E72D297353CC}">
+                <c16:uniqueId val="{00000000-C6D5-464B-9D5C-584E4CFB2392}"/>
+              </c:ext>
+            </c:extLst>
+          </c:dPt>
+          <c:dPt>
+            <c:idx val="1"/>
+            <c:invertIfNegative val="0"/>
+            <c:bubble3D val="0"/>
+            <c:spPr>
+              <a:solidFill>
+                <a:srgbClr val="A9BCC5"/>
+              </a:solidFill>
+            </c:spPr>
+            <c:extLst>
+              <c:ext xmlns:c16="http://schemas.microsoft.com/office/drawing/2014/chart" uri="{C3380CC4-5D6E-409C-BE32-E72D297353CC}">
+                <c16:uniqueId val="{00000002-C6D5-464B-9D5C-584E4CFB2392}"/>
+              </c:ext>
+            </c:extLst>
+          </c:dPt>
+          <c:cat>
+            <c:strRef>
+              <c:f>Latency!$A$2:$A$3</c:f>
+              <c:strCache>
+                <c:ptCount val="2"/>
+                <c:pt idx="0">
+                  <c:v>Rule-based</c:v>
+                </c:pt>
+                <c:pt idx="1">
+                  <c:v>LLM</c:v>
+                </c:pt>
+              </c:strCache>
+            </c:strRef>
+          </c:cat>
+          <c:val>
+            <c:numRef>
+              <c:f>Latency!$B$2:$B$3</c:f>
+              <c:numCache>
+                <c:formatCode>0.000</c:formatCode>
+                <c:ptCount val="2"/>
+                <c:pt idx="0">
+                  <c:v>1.3</c:v>
+                </c:pt>
+                <c:pt idx="1">
+                  <c:v>5.8</c:v>
+                </c:pt>
+              </c:numCache>
+            </c:numRef>
+          </c:val>
+          <c:extLst>
+            <c:ext xmlns:c14="http://schemas.microsoft.com/office/drawing/2007/8/2/chart" uri="{6F2FDCE9-48DA-4B69-8628-5D25D57E5C99}">
+              <c14:invertSolidFillFmt>
+                <c14:spPr xmlns:c14="http://schemas.microsoft.com/office/drawing/2007/8/2/chart">
+                  <a:solidFill>
+                    <a:srgbClr val="FFFFFF"/>
+                  </a:solidFill>
+                </c14:spPr>
+              </c14:invertSolidFillFmt>
+            </c:ext>
+            <c:ext xmlns:c16="http://schemas.microsoft.com/office/drawing/2014/chart" uri="{C3380CC4-5D6E-409C-BE32-E72D297353CC}">
+              <c16:uniqueId val="{00000003-C6D5-464B-9D5C-584E4CFB2392}"/>
+            </c:ext>
+          </c:extLst>
+        </c:ser>
+        <c:dLbls>
+          <c:showLegendKey val="0"/>
+          <c:showVal val="0"/>
+          <c:showCatName val="0"/>
+          <c:showSerName val="0"/>
+          <c:showPercent val="0"/>
+          <c:showBubbleSize val="0"/>
+        </c:dLbls>
+        <c:gapWidth val="100"/>
+        <c:axId val="48650112"/>
+        <c:axId val="48672768"/>
+      </c:barChart>
+      <c:catAx>
+        <c:axId val="48650112"/>
+        <c:scaling>
+          <c:orientation val="minMax"/>
+        </c:scaling>
+        <c:delete val="0"/>
+        <c:axPos val="b"/>
+        <c:numFmt formatCode="General" sourceLinked="1"/>
+        <c:majorTickMark val="none"/>
+        <c:minorTickMark val="none"/>
+        <c:tickLblPos val="nextTo"/>
+        <c:spPr>
+          <a:ln w="9525">
+            <a:solidFill>
+              <a:srgbClr val="7A9AAB"/>
+            </a:solidFill>
+          </a:ln>
+        </c:spPr>
+        <c:txPr>
+          <a:bodyPr anchorCtr="1"/>
+          <a:lstStyle/>
+          <a:p>
+            <a:pPr>
+              <a:defRPr sz="2325">
+                <a:solidFill>
+                  <a:srgbClr val="26333C"/>
+                </a:solidFill>
+                <a:latin typeface="Noto Sans"/>
+                <a:ea typeface="Noto Sans"/>
+                <a:cs typeface="Noto Sans"/>
+              </a:defRPr>
+            </a:pPr>
+            <a:endParaRPr lang="en-US"/>
+          </a:p>
+        </c:txPr>
+        <c:crossAx val="48672768"/>
+        <c:crosses val="autoZero"/>
+        <c:auto val="1"/>
+        <c:lblAlgn val="ctr"/>
+        <c:lblOffset val="100"/>
+        <c:noMultiLvlLbl val="1"/>
+      </c:catAx>
+      <c:valAx>
+        <c:axId val="48672768"/>
+        <c:scaling>
+          <c:orientation val="minMax"/>
+        </c:scaling>
+        <c:delete val="0"/>
+        <c:axPos val="l"/>
+        <c:numFmt formatCode="0.000" sourceLinked="1"/>
+        <c:majorTickMark val="none"/>
+        <c:minorTickMark val="none"/>
+        <c:tickLblPos val="none"/>
+        <c:spPr>
+          <a:ln w="9525">
+            <a:solidFill>
+              <a:srgbClr val="7A9AAB"/>
+            </a:solidFill>
+          </a:ln>
+        </c:spPr>
+        <c:txPr>
+          <a:bodyPr anchorCtr="1"/>
+          <a:lstStyle/>
+          <a:p>
+            <a:pPr>
+              <a:defRPr>
+                <a:solidFill>
+                  <a:srgbClr val="666666"/>
+                </a:solidFill>
+                <a:latin typeface="Noto Sans"/>
+                <a:ea typeface="Noto Sans"/>
+                <a:cs typeface="Noto Sans"/>
+              </a:defRPr>
+            </a:pPr>
+            <a:endParaRPr lang="en-US"/>
+          </a:p>
+        </c:txPr>
+        <c:crossAx val="48650112"/>
+        <c:crosses val="autoZero"/>
+        <c:crossBetween val="between"/>
+      </c:valAx>
+      <c:spPr>
+        <a:solidFill>
+          <a:srgbClr val="DDECF2"/>
+        </a:solidFill>
+        <a:ln w="0">
+          <a:noFill/>
+        </a:ln>
+      </c:spPr>
+    </c:plotArea>
+    <c:plotVisOnly val="1"/>
+    <c:dispBlanksAs val="gap"/>
+    <c:showDLblsOverMax val="1"/>
+  </c:chart>
+  <c:spPr>
+    <a:solidFill>
+      <a:srgbClr val="DDECF2"/>
+    </a:solidFill>
+    <a:ln w="0">
+      <a:noFill/>
+    </a:ln>
+  </c:spPr>
+  <c:externalData r:id="rId1">
+    <c:autoUpdate val="0"/>
+  </c:externalData>
+</c:chartSpace>
 </file>
 
 <file path=ppt/notesMasters/notesMaster1.xml><?xml version="1.0" encoding="utf-8"?>
@@ -1140,7 +1384,7 @@
         </p:blipFill>
         <p:spPr>
           <a:xfrm>
-            <a:off x="18365191" y="309343"/>
+            <a:off x="17979301" y="522392"/>
             <a:ext cx="2770682" cy="3234615"/>
           </a:xfrm>
           <a:prstGeom prst="rect">
@@ -2087,7 +2331,7 @@
         </p:blipFill>
         <p:spPr>
           <a:xfrm>
-            <a:off x="17673572" y="28496233"/>
+            <a:off x="17673572" y="28676558"/>
             <a:ext cx="2900803" cy="1470975"/>
           </a:xfrm>
           <a:prstGeom prst="rect">
@@ -2111,7 +2355,7 @@
         </p:nvSpPr>
         <p:spPr>
           <a:xfrm>
-            <a:off x="977686" y="28707845"/>
+            <a:off x="977686" y="28807857"/>
             <a:ext cx="8096250" cy="523875"/>
           </a:xfrm>
           <a:prstGeom prst="rect">
@@ -2179,7 +2423,7 @@
         </p:nvSpPr>
         <p:spPr>
           <a:xfrm>
-            <a:off x="957171" y="29127526"/>
+            <a:off x="957171" y="29227538"/>
             <a:ext cx="8286750" cy="731732"/>
           </a:xfrm>
           <a:prstGeom prst="rect">
@@ -2561,7 +2805,7 @@
         </p:nvSpPr>
         <p:spPr>
           <a:xfrm>
-            <a:off x="16204855" y="10759143"/>
+            <a:off x="16200085" y="10800657"/>
             <a:ext cx="4405406" cy="1795466"/>
           </a:xfrm>
           <a:prstGeom prst="roundRect">
@@ -2600,7 +2844,7 @@
         </p:nvSpPr>
         <p:spPr>
           <a:xfrm>
-            <a:off x="11164809" y="10764904"/>
+            <a:off x="11160039" y="10806418"/>
             <a:ext cx="4405406" cy="1795466"/>
           </a:xfrm>
           <a:prstGeom prst="roundRect">
@@ -2639,7 +2883,7 @@
         </p:nvSpPr>
         <p:spPr>
           <a:xfrm>
-            <a:off x="6143022" y="10770665"/>
+            <a:off x="6138252" y="10812179"/>
             <a:ext cx="4405406" cy="1795466"/>
           </a:xfrm>
           <a:prstGeom prst="roundRect">
@@ -2678,7 +2922,7 @@
         </p:nvSpPr>
         <p:spPr>
           <a:xfrm>
-            <a:off x="1121235" y="10776604"/>
+            <a:off x="1116465" y="10818118"/>
             <a:ext cx="4405406" cy="1795466"/>
           </a:xfrm>
           <a:prstGeom prst="roundRect">
@@ -2717,7 +2961,7 @@
         </p:nvSpPr>
         <p:spPr>
           <a:xfrm>
-            <a:off x="997410" y="10681355"/>
+            <a:off x="992640" y="10722869"/>
             <a:ext cx="4405406" cy="1765544"/>
           </a:xfrm>
           <a:prstGeom prst="roundRect">
@@ -2756,7 +3000,7 @@
         </p:nvSpPr>
         <p:spPr>
           <a:xfrm>
-            <a:off x="1242775" y="10759490"/>
+            <a:off x="1238005" y="10801004"/>
             <a:ext cx="3986306" cy="545714"/>
           </a:xfrm>
           <a:prstGeom prst="rect">
@@ -2843,7 +3087,7 @@
         </p:nvSpPr>
         <p:spPr>
           <a:xfrm>
-            <a:off x="6021941" y="10681355"/>
+            <a:off x="6017171" y="10722869"/>
             <a:ext cx="4405406" cy="1765544"/>
           </a:xfrm>
           <a:prstGeom prst="roundRect">
@@ -2882,7 +3126,7 @@
         </p:nvSpPr>
         <p:spPr>
           <a:xfrm>
-            <a:off x="6230462" y="10777427"/>
+            <a:off x="6225692" y="10818941"/>
             <a:ext cx="3986306" cy="545714"/>
           </a:xfrm>
           <a:prstGeom prst="rect">
@@ -2969,7 +3213,7 @@
         </p:nvSpPr>
         <p:spPr>
           <a:xfrm>
-            <a:off x="11046473" y="10681355"/>
+            <a:off x="11041703" y="10722869"/>
             <a:ext cx="4405406" cy="1765544"/>
           </a:xfrm>
           <a:prstGeom prst="roundRect">
@@ -3008,7 +3252,7 @@
         </p:nvSpPr>
         <p:spPr>
           <a:xfrm>
-            <a:off x="11254994" y="10777427"/>
+            <a:off x="11250224" y="10818941"/>
             <a:ext cx="3986306" cy="545714"/>
           </a:xfrm>
           <a:prstGeom prst="rect">
@@ -3106,7 +3350,7 @@
         </p:nvSpPr>
         <p:spPr>
           <a:xfrm>
-            <a:off x="11232027" y="11325781"/>
+            <a:off x="11227257" y="11367295"/>
             <a:ext cx="4024406" cy="963024"/>
           </a:xfrm>
           <a:prstGeom prst="rect">
@@ -3185,7 +3429,7 @@
         </p:nvSpPr>
         <p:spPr>
           <a:xfrm>
-            <a:off x="16071004" y="10681355"/>
+            <a:off x="16066234" y="10722869"/>
             <a:ext cx="4405406" cy="1765544"/>
           </a:xfrm>
           <a:prstGeom prst="roundRect">
@@ -3224,7 +3468,7 @@
         </p:nvSpPr>
         <p:spPr>
           <a:xfrm>
-            <a:off x="16204206" y="10777427"/>
+            <a:off x="16199436" y="10818941"/>
             <a:ext cx="3986306" cy="545714"/>
           </a:xfrm>
           <a:prstGeom prst="rect">
@@ -3289,7 +3533,7 @@
         </p:nvSpPr>
         <p:spPr>
           <a:xfrm>
-            <a:off x="16256558" y="11359119"/>
+            <a:off x="16251788" y="11400633"/>
             <a:ext cx="4024406" cy="963024"/>
           </a:xfrm>
           <a:prstGeom prst="rect">
@@ -3355,7 +3599,7 @@
         </p:nvCxnSpPr>
         <p:spPr>
           <a:xfrm>
-            <a:off x="5402816" y="11564127"/>
+            <a:off x="5398046" y="11605641"/>
             <a:ext cx="619125" cy="0"/>
           </a:xfrm>
           <a:prstGeom prst="straightConnector1">
@@ -3386,7 +3630,7 @@
         </p:nvCxnSpPr>
         <p:spPr>
           <a:xfrm>
-            <a:off x="10427347" y="11564127"/>
+            <a:off x="10422577" y="11605641"/>
             <a:ext cx="619126" cy="0"/>
           </a:xfrm>
           <a:prstGeom prst="straightConnector1">
@@ -3417,7 +3661,7 @@
         </p:nvCxnSpPr>
         <p:spPr>
           <a:xfrm>
-            <a:off x="15451879" y="11564127"/>
+            <a:off x="15447109" y="11605641"/>
             <a:ext cx="619125" cy="0"/>
           </a:xfrm>
           <a:prstGeom prst="straightConnector1">
@@ -3447,7 +3691,7 @@
         </p:nvSpPr>
         <p:spPr>
           <a:xfrm>
-            <a:off x="1242775" y="11448079"/>
+            <a:off x="1238005" y="11489593"/>
             <a:ext cx="3968512" cy="919788"/>
           </a:xfrm>
           <a:prstGeom prst="rect">
@@ -3512,7 +3756,7 @@
         </p:nvSpPr>
         <p:spPr>
           <a:xfrm>
-            <a:off x="6431681" y="11346473"/>
+            <a:off x="6426911" y="11387987"/>
             <a:ext cx="3588804" cy="919788"/>
           </a:xfrm>
           <a:prstGeom prst="rect">
@@ -3575,7 +3819,7 @@
         </p:nvGrpSpPr>
         <p:grpSpPr>
           <a:xfrm>
-            <a:off x="982456" y="13454153"/>
+            <a:off x="977686" y="13495667"/>
             <a:ext cx="4524375" cy="3095625"/>
             <a:chOff x="973169" y="13194220"/>
             <a:chExt cx="4524375" cy="3095625"/>
@@ -4421,7 +4665,7 @@
         </p:nvGrpSpPr>
         <p:grpSpPr>
           <a:xfrm>
-            <a:off x="6006989" y="13454153"/>
+            <a:off x="6002219" y="13495667"/>
             <a:ext cx="4524375" cy="3095625"/>
             <a:chOff x="5997702" y="13194220"/>
             <a:chExt cx="4524375" cy="3095625"/>
@@ -5326,7 +5570,7 @@
         </p:nvGrpSpPr>
         <p:grpSpPr>
           <a:xfrm>
-            <a:off x="11031522" y="13454153"/>
+            <a:off x="11026752" y="13495667"/>
             <a:ext cx="4524375" cy="3095625"/>
             <a:chOff x="11022235" y="13194220"/>
             <a:chExt cx="4524375" cy="3095625"/>
@@ -6120,7 +6364,7 @@
         </p:nvGrpSpPr>
         <p:grpSpPr>
           <a:xfrm>
-            <a:off x="16056055" y="13454153"/>
+            <a:off x="16051285" y="13495667"/>
             <a:ext cx="4524375" cy="3095625"/>
             <a:chOff x="16046768" y="13194220"/>
             <a:chExt cx="4524375" cy="3095625"/>
@@ -6916,7 +7160,7 @@
         </p:nvSpPr>
         <p:spPr>
           <a:xfrm>
-            <a:off x="18268807" y="12509083"/>
+            <a:off x="18264037" y="12550597"/>
             <a:ext cx="9525" cy="552450"/>
           </a:xfrm>
           <a:custGeom>
@@ -6968,7 +7212,7 @@
         </p:nvSpPr>
         <p:spPr>
           <a:xfrm>
-            <a:off x="3185160" y="13061533"/>
+            <a:off x="3180390" y="13103047"/>
             <a:ext cx="15073598" cy="9525"/>
           </a:xfrm>
           <a:custGeom>
@@ -7020,7 +7264,7 @@
         </p:nvSpPr>
         <p:spPr>
           <a:xfrm>
-            <a:off x="3185160" y="13061533"/>
+            <a:off x="3180390" y="13103047"/>
             <a:ext cx="9525" cy="276225"/>
           </a:xfrm>
           <a:custGeom>
@@ -7072,7 +7316,7 @@
         </p:nvSpPr>
         <p:spPr>
           <a:xfrm>
-            <a:off x="3147059" y="13314057"/>
+            <a:off x="3142289" y="13355571"/>
             <a:ext cx="76200" cy="133350"/>
           </a:xfrm>
           <a:prstGeom prst="downArrow">
@@ -7109,7 +7353,7 @@
         </p:nvSpPr>
         <p:spPr>
           <a:xfrm>
-            <a:off x="8209693" y="13061533"/>
+            <a:off x="8204923" y="13103047"/>
             <a:ext cx="9525" cy="276225"/>
           </a:xfrm>
           <a:custGeom>
@@ -7161,7 +7405,7 @@
         </p:nvSpPr>
         <p:spPr>
           <a:xfrm>
-            <a:off x="8171592" y="13317257"/>
+            <a:off x="8166822" y="13358771"/>
             <a:ext cx="76200" cy="133350"/>
           </a:xfrm>
           <a:prstGeom prst="downArrow">
@@ -7198,7 +7442,7 @@
         </p:nvSpPr>
         <p:spPr>
           <a:xfrm>
-            <a:off x="13234226" y="13061533"/>
+            <a:off x="13229456" y="13103047"/>
             <a:ext cx="9525" cy="276225"/>
           </a:xfrm>
           <a:custGeom>
@@ -7250,7 +7494,7 @@
         </p:nvSpPr>
         <p:spPr>
           <a:xfrm>
-            <a:off x="13196125" y="13299658"/>
+            <a:off x="13191355" y="13341172"/>
             <a:ext cx="76200" cy="133350"/>
           </a:xfrm>
           <a:prstGeom prst="downArrow">
@@ -7287,7 +7531,7 @@
         </p:nvSpPr>
         <p:spPr>
           <a:xfrm>
-            <a:off x="18268282" y="13057794"/>
+            <a:off x="18263512" y="13099308"/>
             <a:ext cx="9525" cy="276225"/>
           </a:xfrm>
           <a:custGeom>
@@ -7339,7 +7583,7 @@
         </p:nvSpPr>
         <p:spPr>
           <a:xfrm>
-            <a:off x="18232432" y="13307185"/>
+            <a:off x="18227662" y="13348699"/>
             <a:ext cx="71700" cy="135347"/>
           </a:xfrm>
           <a:prstGeom prst="downArrow">
@@ -7376,7 +7620,7 @@
         </p:nvSpPr>
         <p:spPr>
           <a:xfrm>
-            <a:off x="9322238" y="12681401"/>
+            <a:off x="9317468" y="12722915"/>
             <a:ext cx="2914380" cy="356171"/>
           </a:xfrm>
           <a:prstGeom prst="rect">
@@ -7472,7 +7716,7 @@
         </p:nvSpPr>
         <p:spPr>
           <a:xfrm>
-            <a:off x="1099003" y="9717498"/>
+            <a:off x="1095375" y="9717332"/>
             <a:ext cx="4879618" cy="796701"/>
           </a:xfrm>
           <a:prstGeom prst="rect">
@@ -7508,7 +7752,7 @@
                 <a:ea typeface="Rubik"/>
                 <a:cs typeface="Rubik"/>
               </a:rPr>
-              <a:t>Pipeline</a:t>
+              <a:t>Method</a:t>
             </a:r>
           </a:p>
           <a:p>
@@ -7634,6 +7878,1754 @@
               <a:ea typeface="Rubik"/>
               <a:cs typeface="Rubik"/>
             </a:endParaRPr>
+          </a:p>
+        </p:txBody>
+      </p:sp>
+      <p:sp>
+        <p:nvSpPr>
+          <p:cNvPr id="475" name="results-comparison-title">
+            <a:extLst>
+              <a:ext uri="{FF2B5EF4-FFF2-40B4-BE49-F238E27FC236}">
+                <a16:creationId xmlns:a16="http://schemas.microsoft.com/office/drawing/2014/main" id="{D90463E7-C401-7681-772A-7A1A3203F7BB}"/>
+              </a:ext>
+            </a:extLst>
+          </p:cNvPr>
+          <p:cNvSpPr>
+            <a:spLocks noGrp="1"/>
+          </p:cNvSpPr>
+          <p:nvPr/>
+        </p:nvSpPr>
+        <p:spPr>
+          <a:xfrm>
+            <a:off x="1336675" y="17691100"/>
+            <a:ext cx="12001500" cy="514350"/>
+          </a:xfrm>
+          <a:prstGeom prst="rect">
+            <a:avLst/>
+          </a:prstGeom>
+          <a:noFill/>
+          <a:ln w="0">
+            <a:noFill/>
+          </a:ln>
+        </p:spPr>
+        <p:txBody>
+          <a:bodyPr wrap="square" lIns="0" tIns="0" rIns="0" bIns="0">
+            <a:noAutofit/>
+          </a:bodyPr>
+          <a:lstStyle>
+            <a:defPPr>
+              <a:defRPr sz="2925" b="1">
+                <a:solidFill>
+                  <a:srgbClr val="22577A"/>
+                </a:solidFill>
+                <a:latin typeface="Rubik"/>
+                <a:ea typeface="Rubik"/>
+                <a:cs typeface="Rubik"/>
+              </a:defRPr>
+            </a:defPPr>
+          </a:lstStyle>
+          <a:p>
+            <a:pPr>
+              <a:defRPr sz="2925" b="1">
+                <a:solidFill>
+                  <a:srgbClr val="22577A"/>
+                </a:solidFill>
+                <a:latin typeface="Rubik"/>
+                <a:ea typeface="Rubik"/>
+                <a:cs typeface="Rubik"/>
+              </a:defRPr>
+            </a:pPr>
+            <a:r>
+              <a:rPr sz="2925" b="1" dirty="0" err="1">
+                <a:solidFill>
+                  <a:srgbClr val="22577A"/>
+                </a:solidFill>
+                <a:latin typeface="Rubik"/>
+                <a:ea typeface="Rubik"/>
+                <a:cs typeface="Rubik"/>
+              </a:rPr>
+              <a:t>Behaviour</a:t>
+            </a:r>
+            <a:r>
+              <a:rPr sz="2925" b="1" dirty="0">
+                <a:solidFill>
+                  <a:srgbClr val="22577A"/>
+                </a:solidFill>
+                <a:latin typeface="Rubik"/>
+                <a:ea typeface="Rubik"/>
+                <a:cs typeface="Rubik"/>
+              </a:rPr>
+              <a:t> comparison across eight scenarios</a:t>
+            </a:r>
+          </a:p>
+        </p:txBody>
+      </p:sp>
+      <p:graphicFrame>
+        <p:nvGraphicFramePr>
+          <p:cNvPr id="476" name="Table 475">
+            <a:extLst>
+              <a:ext uri="{FF2B5EF4-FFF2-40B4-BE49-F238E27FC236}">
+                <a16:creationId xmlns:a16="http://schemas.microsoft.com/office/drawing/2014/main" id="{02FE7138-D1E3-D28A-53DC-EEB76EB1795C}"/>
+              </a:ext>
+            </a:extLst>
+          </p:cNvPr>
+          <p:cNvGraphicFramePr/>
+          <p:nvPr>
+            <p:extLst>
+              <p:ext uri="{D42A27DB-BD31-4B8C-83A1-F6EECF244321}">
+                <p14:modId xmlns:p14="http://schemas.microsoft.com/office/powerpoint/2010/main" val="2428378323"/>
+              </p:ext>
+            </p:extLst>
+          </p:nvPr>
+        </p:nvGraphicFramePr>
+        <p:xfrm>
+          <a:off x="1336675" y="18319750"/>
+          <a:ext cx="11477625" cy="4987290"/>
+        </p:xfrm>
+        <a:graphic>
+          <a:graphicData uri="http://schemas.openxmlformats.org/drawingml/2006/table">
+            <a:tbl>
+              <a:tblPr/>
+              <a:tblGrid>
+                <a:gridCol w="3909409">
+                  <a:extLst>
+                    <a:ext uri="{9D8B030D-6E8A-4147-A177-3AD203B41FA5}">
+                      <a16:colId xmlns:a16="http://schemas.microsoft.com/office/drawing/2014/main" val="20001"/>
+                    </a:ext>
+                  </a:extLst>
+                </a:gridCol>
+                <a:gridCol w="3257841">
+                  <a:extLst>
+                    <a:ext uri="{9D8B030D-6E8A-4147-A177-3AD203B41FA5}">
+                      <a16:colId xmlns:a16="http://schemas.microsoft.com/office/drawing/2014/main" val="20002"/>
+                    </a:ext>
+                  </a:extLst>
+                </a:gridCol>
+                <a:gridCol w="2305549">
+                  <a:extLst>
+                    <a:ext uri="{9D8B030D-6E8A-4147-A177-3AD203B41FA5}">
+                      <a16:colId xmlns:a16="http://schemas.microsoft.com/office/drawing/2014/main" val="20003"/>
+                    </a:ext>
+                  </a:extLst>
+                </a:gridCol>
+                <a:gridCol w="2004826">
+                  <a:extLst>
+                    <a:ext uri="{9D8B030D-6E8A-4147-A177-3AD203B41FA5}">
+                      <a16:colId xmlns:a16="http://schemas.microsoft.com/office/drawing/2014/main" val="20004"/>
+                    </a:ext>
+                  </a:extLst>
+                </a:gridCol>
+              </a:tblGrid>
+              <a:tr h="723900">
+                <a:tc>
+                  <a:txBody>
+                    <a:bodyPr/>
+                    <a:lstStyle/>
+                    <a:p>
+                      <a:pPr algn="l"/>
+                      <a:r>
+                        <a:rPr sz="2175" b="1" dirty="0">
+                          <a:solidFill>
+                            <a:srgbClr val="FFFFFF"/>
+                          </a:solidFill>
+                          <a:latin typeface="Noto Sans"/>
+                          <a:ea typeface="Noto Sans"/>
+                          <a:cs typeface="Noto Sans"/>
+                        </a:rPr>
+                        <a:t>Description</a:t>
+                      </a:r>
+                      <a:r>
+                        <a:rPr lang="en-AU" sz="2175" b="1" dirty="0">
+                          <a:solidFill>
+                            <a:srgbClr val="FFFFFF"/>
+                          </a:solidFill>
+                          <a:latin typeface="Noto Sans"/>
+                          <a:ea typeface="Noto Sans"/>
+                          <a:cs typeface="Noto Sans"/>
+                        </a:rPr>
+                        <a:t> (Human)</a:t>
+                      </a:r>
+                      <a:endParaRPr sz="2175" b="1" dirty="0">
+                        <a:solidFill>
+                          <a:srgbClr val="FFFFFF"/>
+                        </a:solidFill>
+                        <a:latin typeface="Noto Sans"/>
+                        <a:ea typeface="Noto Sans"/>
+                        <a:cs typeface="Noto Sans"/>
+                      </a:endParaRPr>
+                    </a:p>
+                  </a:txBody>
+                  <a:tcPr marL="95250" marR="95250" marT="66675" marB="66675" anchor="ctr">
+                    <a:solidFill>
+                      <a:srgbClr val="22577A"/>
+                    </a:solidFill>
+                  </a:tcPr>
+                </a:tc>
+                <a:tc>
+                  <a:txBody>
+                    <a:bodyPr/>
+                    <a:lstStyle/>
+                    <a:p>
+                      <a:pPr algn="ctr"/>
+                      <a:r>
+                        <a:rPr sz="2175" b="1">
+                          <a:solidFill>
+                            <a:srgbClr val="FFFFFF"/>
+                          </a:solidFill>
+                          <a:latin typeface="Noto Sans"/>
+                          <a:ea typeface="Noto Sans"/>
+                          <a:cs typeface="Noto Sans"/>
+                        </a:rPr>
+                        <a:t>Survey preference</a:t>
+                      </a:r>
+                    </a:p>
+                    <a:p>
+                      <a:pPr algn="ctr"/>
+                      <a:r>
+                        <a:rPr sz="2175" b="1">
+                          <a:solidFill>
+                            <a:srgbClr val="FFFFFF"/>
+                          </a:solidFill>
+                          <a:latin typeface="Noto Sans"/>
+                          <a:ea typeface="Noto Sans"/>
+                          <a:cs typeface="Noto Sans"/>
+                        </a:rPr>
+                        <a:t>(action and %)</a:t>
+                      </a:r>
+                    </a:p>
+                  </a:txBody>
+                  <a:tcPr marL="95250" marR="95250" marT="66675" marB="66675" anchor="ctr">
+                    <a:solidFill>
+                      <a:srgbClr val="22577A"/>
+                    </a:solidFill>
+                  </a:tcPr>
+                </a:tc>
+                <a:tc>
+                  <a:txBody>
+                    <a:bodyPr/>
+                    <a:lstStyle/>
+                    <a:p>
+                      <a:pPr algn="ctr"/>
+                      <a:r>
+                        <a:rPr sz="2175" b="1">
+                          <a:solidFill>
+                            <a:srgbClr val="FFFFFF"/>
+                          </a:solidFill>
+                          <a:latin typeface="Noto Sans"/>
+                          <a:ea typeface="Noto Sans"/>
+                          <a:cs typeface="Noto Sans"/>
+                        </a:rPr>
+                        <a:t>Rule-based</a:t>
+                      </a:r>
+                    </a:p>
+                  </a:txBody>
+                  <a:tcPr marL="95250" marR="95250" marT="66675" marB="66675" anchor="ctr">
+                    <a:solidFill>
+                      <a:srgbClr val="22577A"/>
+                    </a:solidFill>
+                  </a:tcPr>
+                </a:tc>
+                <a:tc>
+                  <a:txBody>
+                    <a:bodyPr/>
+                    <a:lstStyle/>
+                    <a:p>
+                      <a:pPr algn="ctr"/>
+                      <a:r>
+                        <a:rPr sz="2175" b="1">
+                          <a:solidFill>
+                            <a:srgbClr val="FFFFFF"/>
+                          </a:solidFill>
+                          <a:latin typeface="Noto Sans"/>
+                          <a:ea typeface="Noto Sans"/>
+                          <a:cs typeface="Noto Sans"/>
+                        </a:rPr>
+                        <a:t>LLM</a:t>
+                      </a:r>
+                    </a:p>
+                  </a:txBody>
+                  <a:tcPr marL="95250" marR="95250" marT="66675" marB="66675" anchor="ctr">
+                    <a:solidFill>
+                      <a:srgbClr val="22577A"/>
+                    </a:solidFill>
+                  </a:tcPr>
+                </a:tc>
+                <a:extLst>
+                  <a:ext uri="{0D108BD9-81ED-4DB2-BD59-A6C34878D82A}">
+                    <a16:rowId xmlns:a16="http://schemas.microsoft.com/office/drawing/2014/main" val="10000"/>
+                  </a:ext>
+                </a:extLst>
+              </a:tr>
+              <a:tr h="523875">
+                <a:tc>
+                  <a:txBody>
+                    <a:bodyPr/>
+                    <a:lstStyle/>
+                    <a:p>
+                      <a:pPr algn="l"/>
+                      <a:r>
+                        <a:rPr lang="en-AU" sz="2000" b="0" dirty="0">
+                          <a:solidFill>
+                            <a:srgbClr val="26333C"/>
+                          </a:solidFill>
+                          <a:latin typeface="Noto Sans"/>
+                          <a:ea typeface="Noto Sans"/>
+                          <a:cs typeface="Noto Sans"/>
+                        </a:rPr>
+                        <a:t>Passes</a:t>
+                      </a:r>
+                      <a:r>
+                        <a:rPr lang="en-US" sz="2000" b="0" dirty="0">
+                          <a:solidFill>
+                            <a:srgbClr val="26333C"/>
+                          </a:solidFill>
+                          <a:latin typeface="Noto Sans"/>
+                          <a:ea typeface="Noto Sans"/>
+                          <a:cs typeface="Noto Sans"/>
+                        </a:rPr>
+                        <a:t> </a:t>
+                      </a:r>
+                      <a:r>
+                        <a:rPr lang="en-AU" sz="2000" b="0" dirty="0">
+                          <a:solidFill>
+                            <a:srgbClr val="26333C"/>
+                          </a:solidFill>
+                          <a:latin typeface="Noto Sans"/>
+                          <a:ea typeface="Noto Sans"/>
+                          <a:cs typeface="Noto Sans"/>
+                        </a:rPr>
+                        <a:t>without</a:t>
+                      </a:r>
+                      <a:r>
+                        <a:rPr lang="en-US" sz="2000" b="0" dirty="0">
+                          <a:solidFill>
+                            <a:srgbClr val="26333C"/>
+                          </a:solidFill>
+                          <a:latin typeface="Noto Sans"/>
+                          <a:ea typeface="Noto Sans"/>
+                          <a:cs typeface="Noto Sans"/>
+                        </a:rPr>
+                        <a:t> </a:t>
+                      </a:r>
+                      <a:r>
+                        <a:rPr lang="en-AU" sz="2000" b="0" dirty="0">
+                          <a:solidFill>
+                            <a:srgbClr val="26333C"/>
+                          </a:solidFill>
+                          <a:latin typeface="Noto Sans"/>
+                          <a:ea typeface="Noto Sans"/>
+                          <a:cs typeface="Noto Sans"/>
+                        </a:rPr>
+                        <a:t>looking</a:t>
+                      </a:r>
+                      <a:endParaRPr sz="2000" b="0" dirty="0">
+                        <a:solidFill>
+                          <a:srgbClr val="26333C"/>
+                        </a:solidFill>
+                        <a:latin typeface="Noto Sans"/>
+                        <a:ea typeface="Noto Sans"/>
+                        <a:cs typeface="Noto Sans"/>
+                      </a:endParaRPr>
+                    </a:p>
+                  </a:txBody>
+                  <a:tcPr marL="95250" marR="95250" marT="66675" marB="66675" anchor="ctr">
+                    <a:solidFill>
+                      <a:srgbClr val="FFFFFF"/>
+                    </a:solidFill>
+                  </a:tcPr>
+                </a:tc>
+                <a:tc>
+                  <a:txBody>
+                    <a:bodyPr/>
+                    <a:lstStyle/>
+                    <a:p>
+                      <a:pPr algn="ctr"/>
+                      <a:r>
+                        <a:rPr lang="en-AU" sz="2325" b="0" dirty="0">
+                          <a:solidFill>
+                            <a:srgbClr val="26333C"/>
+                          </a:solidFill>
+                          <a:latin typeface="Noto Sans"/>
+                          <a:ea typeface="Noto Sans"/>
+                          <a:cs typeface="Noto Sans"/>
+                        </a:rPr>
+                        <a:t>CONTINUE </a:t>
+                      </a:r>
+                      <a:r>
+                        <a:rPr sz="2325" b="0" dirty="0">
+                          <a:solidFill>
+                            <a:srgbClr val="26333C"/>
+                          </a:solidFill>
+                          <a:latin typeface="Noto Sans"/>
+                          <a:ea typeface="Noto Sans"/>
+                          <a:cs typeface="Noto Sans"/>
+                        </a:rPr>
+                        <a:t>(</a:t>
+                      </a:r>
+                      <a:r>
+                        <a:rPr lang="en-AU" sz="2325" b="0" dirty="0">
+                          <a:solidFill>
+                            <a:srgbClr val="26333C"/>
+                          </a:solidFill>
+                          <a:latin typeface="Noto Sans"/>
+                          <a:ea typeface="Noto Sans"/>
+                          <a:cs typeface="Noto Sans"/>
+                        </a:rPr>
+                        <a:t>83.3</a:t>
+                      </a:r>
+                      <a:r>
+                        <a:rPr sz="2325" b="0" dirty="0">
+                          <a:solidFill>
+                            <a:srgbClr val="26333C"/>
+                          </a:solidFill>
+                          <a:latin typeface="Noto Sans"/>
+                          <a:ea typeface="Noto Sans"/>
+                          <a:cs typeface="Noto Sans"/>
+                        </a:rPr>
+                        <a:t>%)</a:t>
+                      </a:r>
+                    </a:p>
+                  </a:txBody>
+                  <a:tcPr marL="95250" marR="95250" marT="66675" marB="66675" anchor="ctr">
+                    <a:solidFill>
+                      <a:srgbClr val="FFFFFF"/>
+                    </a:solidFill>
+                  </a:tcPr>
+                </a:tc>
+                <a:tc>
+                  <a:txBody>
+                    <a:bodyPr/>
+                    <a:lstStyle/>
+                    <a:p>
+                      <a:pPr algn="ctr"/>
+                      <a:r>
+                        <a:rPr sz="2325" b="0" dirty="0">
+                          <a:solidFill>
+                            <a:srgbClr val="26333C"/>
+                          </a:solidFill>
+                          <a:latin typeface="Noto Sans"/>
+                          <a:ea typeface="Noto Sans"/>
+                          <a:cs typeface="Noto Sans"/>
+                        </a:rPr>
+                        <a:t>[Action]</a:t>
+                      </a:r>
+                    </a:p>
+                  </a:txBody>
+                  <a:tcPr marL="95250" marR="95250" marT="66675" marB="66675" anchor="ctr">
+                    <a:solidFill>
+                      <a:srgbClr val="FFFFFF"/>
+                    </a:solidFill>
+                  </a:tcPr>
+                </a:tc>
+                <a:tc>
+                  <a:txBody>
+                    <a:bodyPr/>
+                    <a:lstStyle/>
+                    <a:p>
+                      <a:pPr algn="ctr"/>
+                      <a:r>
+                        <a:rPr sz="2325" b="0">
+                          <a:solidFill>
+                            <a:srgbClr val="26333C"/>
+                          </a:solidFill>
+                          <a:latin typeface="Noto Sans"/>
+                          <a:ea typeface="Noto Sans"/>
+                          <a:cs typeface="Noto Sans"/>
+                        </a:rPr>
+                        <a:t>[Action]</a:t>
+                      </a:r>
+                    </a:p>
+                  </a:txBody>
+                  <a:tcPr marL="95250" marR="95250" marT="66675" marB="66675" anchor="ctr">
+                    <a:solidFill>
+                      <a:srgbClr val="FFFFFF"/>
+                    </a:solidFill>
+                  </a:tcPr>
+                </a:tc>
+                <a:extLst>
+                  <a:ext uri="{0D108BD9-81ED-4DB2-BD59-A6C34878D82A}">
+                    <a16:rowId xmlns:a16="http://schemas.microsoft.com/office/drawing/2014/main" val="10001"/>
+                  </a:ext>
+                </a:extLst>
+              </a:tr>
+              <a:tr h="523875">
+                <a:tc>
+                  <a:txBody>
+                    <a:bodyPr/>
+                    <a:lstStyle/>
+                    <a:p>
+                      <a:pPr algn="l"/>
+                      <a:r>
+                        <a:rPr lang="en-AU" sz="2000" b="0" dirty="0">
+                          <a:solidFill>
+                            <a:srgbClr val="26333C"/>
+                          </a:solidFill>
+                          <a:latin typeface="Noto Sans"/>
+                          <a:ea typeface="Noto Sans"/>
+                          <a:cs typeface="Noto Sans"/>
+                        </a:rPr>
+                        <a:t>Beside route, sustained gaze</a:t>
+                      </a:r>
+                      <a:endParaRPr sz="2000" b="0" dirty="0">
+                        <a:solidFill>
+                          <a:srgbClr val="26333C"/>
+                        </a:solidFill>
+                        <a:latin typeface="Noto Sans"/>
+                        <a:ea typeface="Noto Sans"/>
+                        <a:cs typeface="Noto Sans"/>
+                      </a:endParaRPr>
+                    </a:p>
+                  </a:txBody>
+                  <a:tcPr marL="95250" marR="95250" marT="66675" marB="66675" anchor="ctr">
+                    <a:solidFill>
+                      <a:srgbClr val="EEF5F7"/>
+                    </a:solidFill>
+                  </a:tcPr>
+                </a:tc>
+                <a:tc>
+                  <a:txBody>
+                    <a:bodyPr/>
+                    <a:lstStyle/>
+                    <a:p>
+                      <a:pPr algn="ctr"/>
+                      <a:r>
+                        <a:rPr lang="en-AU" sz="2325" b="0" dirty="0">
+                          <a:solidFill>
+                            <a:srgbClr val="26333C"/>
+                          </a:solidFill>
+                          <a:latin typeface="Noto Sans"/>
+                          <a:ea typeface="Noto Sans"/>
+                          <a:cs typeface="Noto Sans"/>
+                        </a:rPr>
+                        <a:t>APPROACH</a:t>
+                      </a:r>
+                      <a:r>
+                        <a:rPr sz="2325" b="0" dirty="0">
+                          <a:solidFill>
+                            <a:srgbClr val="26333C"/>
+                          </a:solidFill>
+                          <a:latin typeface="Noto Sans"/>
+                          <a:ea typeface="Noto Sans"/>
+                          <a:cs typeface="Noto Sans"/>
+                        </a:rPr>
+                        <a:t> (</a:t>
+                      </a:r>
+                      <a:r>
+                        <a:rPr lang="en-AU" sz="2325" b="0" dirty="0">
+                          <a:solidFill>
+                            <a:srgbClr val="26333C"/>
+                          </a:solidFill>
+                          <a:latin typeface="Noto Sans"/>
+                          <a:ea typeface="Noto Sans"/>
+                          <a:cs typeface="Noto Sans"/>
+                        </a:rPr>
+                        <a:t>45.2</a:t>
+                      </a:r>
+                      <a:r>
+                        <a:rPr sz="2325" b="0" dirty="0">
+                          <a:solidFill>
+                            <a:srgbClr val="26333C"/>
+                          </a:solidFill>
+                          <a:latin typeface="Noto Sans"/>
+                          <a:ea typeface="Noto Sans"/>
+                          <a:cs typeface="Noto Sans"/>
+                        </a:rPr>
+                        <a:t>%)</a:t>
+                      </a:r>
+                    </a:p>
+                  </a:txBody>
+                  <a:tcPr marL="95250" marR="95250" marT="66675" marB="66675" anchor="ctr">
+                    <a:solidFill>
+                      <a:srgbClr val="EEF5F7"/>
+                    </a:solidFill>
+                  </a:tcPr>
+                </a:tc>
+                <a:tc>
+                  <a:txBody>
+                    <a:bodyPr/>
+                    <a:lstStyle/>
+                    <a:p>
+                      <a:pPr algn="ctr"/>
+                      <a:r>
+                        <a:rPr sz="2325" b="0">
+                          <a:solidFill>
+                            <a:srgbClr val="26333C"/>
+                          </a:solidFill>
+                          <a:latin typeface="Noto Sans"/>
+                          <a:ea typeface="Noto Sans"/>
+                          <a:cs typeface="Noto Sans"/>
+                        </a:rPr>
+                        <a:t>[Action]</a:t>
+                      </a:r>
+                    </a:p>
+                  </a:txBody>
+                  <a:tcPr marL="95250" marR="95250" marT="66675" marB="66675" anchor="ctr">
+                    <a:solidFill>
+                      <a:srgbClr val="EEF5F7"/>
+                    </a:solidFill>
+                  </a:tcPr>
+                </a:tc>
+                <a:tc>
+                  <a:txBody>
+                    <a:bodyPr/>
+                    <a:lstStyle/>
+                    <a:p>
+                      <a:pPr algn="ctr"/>
+                      <a:r>
+                        <a:rPr sz="2325" b="0">
+                          <a:solidFill>
+                            <a:srgbClr val="26333C"/>
+                          </a:solidFill>
+                          <a:latin typeface="Noto Sans"/>
+                          <a:ea typeface="Noto Sans"/>
+                          <a:cs typeface="Noto Sans"/>
+                        </a:rPr>
+                        <a:t>[Action]</a:t>
+                      </a:r>
+                    </a:p>
+                  </a:txBody>
+                  <a:tcPr marL="95250" marR="95250" marT="66675" marB="66675" anchor="ctr">
+                    <a:solidFill>
+                      <a:srgbClr val="EEF5F7"/>
+                    </a:solidFill>
+                  </a:tcPr>
+                </a:tc>
+                <a:extLst>
+                  <a:ext uri="{0D108BD9-81ED-4DB2-BD59-A6C34878D82A}">
+                    <a16:rowId xmlns:a16="http://schemas.microsoft.com/office/drawing/2014/main" val="10002"/>
+                  </a:ext>
+                </a:extLst>
+              </a:tr>
+              <a:tr h="523875">
+                <a:tc>
+                  <a:txBody>
+                    <a:bodyPr/>
+                    <a:lstStyle/>
+                    <a:p>
+                      <a:pPr algn="l"/>
+                      <a:r>
+                        <a:rPr lang="en-AU" sz="2000" b="0" dirty="0">
+                          <a:solidFill>
+                            <a:srgbClr val="26333C"/>
+                          </a:solidFill>
+                          <a:latin typeface="Noto Sans"/>
+                          <a:ea typeface="Noto Sans"/>
+                          <a:cs typeface="Noto Sans"/>
+                        </a:rPr>
+                        <a:t>Already nearby, sustained gaze</a:t>
+                      </a:r>
+                      <a:endParaRPr sz="2000" b="0" dirty="0">
+                        <a:solidFill>
+                          <a:srgbClr val="26333C"/>
+                        </a:solidFill>
+                        <a:latin typeface="Noto Sans"/>
+                        <a:ea typeface="Noto Sans"/>
+                        <a:cs typeface="Noto Sans"/>
+                      </a:endParaRPr>
+                    </a:p>
+                  </a:txBody>
+                  <a:tcPr marL="95250" marR="95250" marT="66675" marB="66675" anchor="ctr">
+                    <a:solidFill>
+                      <a:srgbClr val="FFFFFF"/>
+                    </a:solidFill>
+                  </a:tcPr>
+                </a:tc>
+                <a:tc>
+                  <a:txBody>
+                    <a:bodyPr/>
+                    <a:lstStyle/>
+                    <a:p>
+                      <a:pPr algn="ctr"/>
+                      <a:r>
+                        <a:rPr lang="en-AU" sz="2325" b="0" dirty="0">
+                          <a:solidFill>
+                            <a:srgbClr val="26333C"/>
+                          </a:solidFill>
+                          <a:latin typeface="Noto Sans"/>
+                          <a:ea typeface="Noto Sans"/>
+                          <a:cs typeface="Noto Sans"/>
+                        </a:rPr>
+                        <a:t>YIELD (42.9%)</a:t>
+                      </a:r>
+                    </a:p>
+                  </a:txBody>
+                  <a:tcPr marL="95250" marR="95250" marT="66675" marB="66675" anchor="ctr">
+                    <a:solidFill>
+                      <a:srgbClr val="FFFFFF"/>
+                    </a:solidFill>
+                  </a:tcPr>
+                </a:tc>
+                <a:tc>
+                  <a:txBody>
+                    <a:bodyPr/>
+                    <a:lstStyle/>
+                    <a:p>
+                      <a:pPr algn="ctr"/>
+                      <a:r>
+                        <a:rPr sz="2325" b="0">
+                          <a:solidFill>
+                            <a:srgbClr val="26333C"/>
+                          </a:solidFill>
+                          <a:latin typeface="Noto Sans"/>
+                          <a:ea typeface="Noto Sans"/>
+                          <a:cs typeface="Noto Sans"/>
+                        </a:rPr>
+                        <a:t>[Action]</a:t>
+                      </a:r>
+                    </a:p>
+                  </a:txBody>
+                  <a:tcPr marL="95250" marR="95250" marT="66675" marB="66675" anchor="ctr">
+                    <a:solidFill>
+                      <a:srgbClr val="FFFFFF"/>
+                    </a:solidFill>
+                  </a:tcPr>
+                </a:tc>
+                <a:tc>
+                  <a:txBody>
+                    <a:bodyPr/>
+                    <a:lstStyle/>
+                    <a:p>
+                      <a:pPr algn="ctr"/>
+                      <a:r>
+                        <a:rPr sz="2325" b="0" dirty="0">
+                          <a:solidFill>
+                            <a:srgbClr val="26333C"/>
+                          </a:solidFill>
+                          <a:latin typeface="Noto Sans"/>
+                          <a:ea typeface="Noto Sans"/>
+                          <a:cs typeface="Noto Sans"/>
+                        </a:rPr>
+                        <a:t>[Action]</a:t>
+                      </a:r>
+                    </a:p>
+                  </a:txBody>
+                  <a:tcPr marL="95250" marR="95250" marT="66675" marB="66675" anchor="ctr">
+                    <a:solidFill>
+                      <a:srgbClr val="FFFFFF"/>
+                    </a:solidFill>
+                  </a:tcPr>
+                </a:tc>
+                <a:extLst>
+                  <a:ext uri="{0D108BD9-81ED-4DB2-BD59-A6C34878D82A}">
+                    <a16:rowId xmlns:a16="http://schemas.microsoft.com/office/drawing/2014/main" val="10003"/>
+                  </a:ext>
+                </a:extLst>
+              </a:tr>
+              <a:tr h="523875">
+                <a:tc>
+                  <a:txBody>
+                    <a:bodyPr/>
+                    <a:lstStyle/>
+                    <a:p>
+                      <a:pPr algn="l"/>
+                      <a:r>
+                        <a:rPr lang="en-AU" sz="2000" b="0" dirty="0">
+                          <a:solidFill>
+                            <a:srgbClr val="26333C"/>
+                          </a:solidFill>
+                          <a:latin typeface="Noto Sans"/>
+                          <a:ea typeface="Noto Sans"/>
+                          <a:cs typeface="Noto Sans"/>
+                        </a:rPr>
+                        <a:t>Approaches on route, no gaze</a:t>
+                      </a:r>
+                      <a:endParaRPr sz="2000" b="0" dirty="0">
+                        <a:solidFill>
+                          <a:srgbClr val="26333C"/>
+                        </a:solidFill>
+                        <a:latin typeface="Noto Sans"/>
+                        <a:ea typeface="Noto Sans"/>
+                        <a:cs typeface="Noto Sans"/>
+                      </a:endParaRPr>
+                    </a:p>
+                  </a:txBody>
+                  <a:tcPr marL="95250" marR="95250" marT="66675" marB="66675" anchor="ctr">
+                    <a:solidFill>
+                      <a:srgbClr val="EEF5F7"/>
+                    </a:solidFill>
+                  </a:tcPr>
+                </a:tc>
+                <a:tc>
+                  <a:txBody>
+                    <a:bodyPr/>
+                    <a:lstStyle/>
+                    <a:p>
+                      <a:pPr algn="ctr"/>
+                      <a:r>
+                        <a:rPr lang="en-AU" sz="2325" b="0" dirty="0">
+                          <a:solidFill>
+                            <a:srgbClr val="26333C"/>
+                          </a:solidFill>
+                          <a:latin typeface="Noto Sans"/>
+                          <a:ea typeface="Noto Sans"/>
+                          <a:cs typeface="Noto Sans"/>
+                        </a:rPr>
+                        <a:t>YIELD (90.5%)</a:t>
+                      </a:r>
+                    </a:p>
+                  </a:txBody>
+                  <a:tcPr marL="95250" marR="95250" marT="66675" marB="66675" anchor="ctr">
+                    <a:solidFill>
+                      <a:srgbClr val="EEF5F7"/>
+                    </a:solidFill>
+                  </a:tcPr>
+                </a:tc>
+                <a:tc>
+                  <a:txBody>
+                    <a:bodyPr/>
+                    <a:lstStyle/>
+                    <a:p>
+                      <a:pPr algn="ctr"/>
+                      <a:r>
+                        <a:rPr sz="2325" b="0">
+                          <a:solidFill>
+                            <a:srgbClr val="26333C"/>
+                          </a:solidFill>
+                          <a:latin typeface="Noto Sans"/>
+                          <a:ea typeface="Noto Sans"/>
+                          <a:cs typeface="Noto Sans"/>
+                        </a:rPr>
+                        <a:t>[Action]</a:t>
+                      </a:r>
+                    </a:p>
+                  </a:txBody>
+                  <a:tcPr marL="95250" marR="95250" marT="66675" marB="66675" anchor="ctr">
+                    <a:solidFill>
+                      <a:srgbClr val="EEF5F7"/>
+                    </a:solidFill>
+                  </a:tcPr>
+                </a:tc>
+                <a:tc>
+                  <a:txBody>
+                    <a:bodyPr/>
+                    <a:lstStyle/>
+                    <a:p>
+                      <a:pPr algn="ctr"/>
+                      <a:r>
+                        <a:rPr sz="2325" b="0">
+                          <a:solidFill>
+                            <a:srgbClr val="26333C"/>
+                          </a:solidFill>
+                          <a:latin typeface="Noto Sans"/>
+                          <a:ea typeface="Noto Sans"/>
+                          <a:cs typeface="Noto Sans"/>
+                        </a:rPr>
+                        <a:t>[Action]</a:t>
+                      </a:r>
+                    </a:p>
+                  </a:txBody>
+                  <a:tcPr marL="95250" marR="95250" marT="66675" marB="66675" anchor="ctr">
+                    <a:solidFill>
+                      <a:srgbClr val="EEF5F7"/>
+                    </a:solidFill>
+                  </a:tcPr>
+                </a:tc>
+                <a:extLst>
+                  <a:ext uri="{0D108BD9-81ED-4DB2-BD59-A6C34878D82A}">
+                    <a16:rowId xmlns:a16="http://schemas.microsoft.com/office/drawing/2014/main" val="10004"/>
+                  </a:ext>
+                </a:extLst>
+              </a:tr>
+              <a:tr h="523875">
+                <a:tc>
+                  <a:txBody>
+                    <a:bodyPr/>
+                    <a:lstStyle/>
+                    <a:p>
+                      <a:pPr algn="l"/>
+                      <a:r>
+                        <a:rPr lang="en-AU" sz="2000" b="0" dirty="0">
+                          <a:solidFill>
+                            <a:srgbClr val="26333C"/>
+                          </a:solidFill>
+                          <a:latin typeface="Noto Sans"/>
+                          <a:ea typeface="Noto Sans"/>
+                          <a:cs typeface="Noto Sans"/>
+                        </a:rPr>
+                        <a:t>Walks away without looking</a:t>
+                      </a:r>
+                      <a:endParaRPr sz="2000" b="0" dirty="0">
+                        <a:solidFill>
+                          <a:srgbClr val="26333C"/>
+                        </a:solidFill>
+                        <a:latin typeface="Noto Sans"/>
+                        <a:ea typeface="Noto Sans"/>
+                        <a:cs typeface="Noto Sans"/>
+                      </a:endParaRPr>
+                    </a:p>
+                  </a:txBody>
+                  <a:tcPr marL="95250" marR="95250" marT="66675" marB="66675" anchor="ctr">
+                    <a:solidFill>
+                      <a:srgbClr val="FFFFFF"/>
+                    </a:solidFill>
+                  </a:tcPr>
+                </a:tc>
+                <a:tc>
+                  <a:txBody>
+                    <a:bodyPr/>
+                    <a:lstStyle/>
+                    <a:p>
+                      <a:pPr algn="ctr"/>
+                      <a:r>
+                        <a:rPr lang="en-AU" sz="2325" b="0" dirty="0">
+                          <a:solidFill>
+                            <a:srgbClr val="26333C"/>
+                          </a:solidFill>
+                          <a:latin typeface="Noto Sans"/>
+                          <a:ea typeface="Noto Sans"/>
+                          <a:cs typeface="Noto Sans"/>
+                        </a:rPr>
+                        <a:t>CONTINUE (57.1%)</a:t>
+                      </a:r>
+                    </a:p>
+                  </a:txBody>
+                  <a:tcPr marL="95250" marR="95250" marT="66675" marB="66675" anchor="ctr">
+                    <a:solidFill>
+                      <a:srgbClr val="FFFFFF"/>
+                    </a:solidFill>
+                  </a:tcPr>
+                </a:tc>
+                <a:tc>
+                  <a:txBody>
+                    <a:bodyPr/>
+                    <a:lstStyle/>
+                    <a:p>
+                      <a:pPr algn="ctr"/>
+                      <a:r>
+                        <a:rPr sz="2325" b="0">
+                          <a:solidFill>
+                            <a:srgbClr val="26333C"/>
+                          </a:solidFill>
+                          <a:latin typeface="Noto Sans"/>
+                          <a:ea typeface="Noto Sans"/>
+                          <a:cs typeface="Noto Sans"/>
+                        </a:rPr>
+                        <a:t>[Action]</a:t>
+                      </a:r>
+                    </a:p>
+                  </a:txBody>
+                  <a:tcPr marL="95250" marR="95250" marT="66675" marB="66675" anchor="ctr">
+                    <a:solidFill>
+                      <a:srgbClr val="FFFFFF"/>
+                    </a:solidFill>
+                  </a:tcPr>
+                </a:tc>
+                <a:tc>
+                  <a:txBody>
+                    <a:bodyPr/>
+                    <a:lstStyle/>
+                    <a:p>
+                      <a:pPr algn="ctr"/>
+                      <a:r>
+                        <a:rPr sz="2325" b="0">
+                          <a:solidFill>
+                            <a:srgbClr val="26333C"/>
+                          </a:solidFill>
+                          <a:latin typeface="Noto Sans"/>
+                          <a:ea typeface="Noto Sans"/>
+                          <a:cs typeface="Noto Sans"/>
+                        </a:rPr>
+                        <a:t>[Action]</a:t>
+                      </a:r>
+                    </a:p>
+                  </a:txBody>
+                  <a:tcPr marL="95250" marR="95250" marT="66675" marB="66675" anchor="ctr">
+                    <a:solidFill>
+                      <a:srgbClr val="FFFFFF"/>
+                    </a:solidFill>
+                  </a:tcPr>
+                </a:tc>
+                <a:extLst>
+                  <a:ext uri="{0D108BD9-81ED-4DB2-BD59-A6C34878D82A}">
+                    <a16:rowId xmlns:a16="http://schemas.microsoft.com/office/drawing/2014/main" val="10005"/>
+                  </a:ext>
+                </a:extLst>
+              </a:tr>
+              <a:tr h="523875">
+                <a:tc>
+                  <a:txBody>
+                    <a:bodyPr/>
+                    <a:lstStyle/>
+                    <a:p>
+                      <a:pPr algn="l"/>
+                      <a:r>
+                        <a:rPr lang="en-AU" sz="2000" b="0" dirty="0">
+                          <a:solidFill>
+                            <a:srgbClr val="26333C"/>
+                          </a:solidFill>
+                          <a:latin typeface="Noto Sans"/>
+                          <a:ea typeface="Noto Sans"/>
+                          <a:cs typeface="Noto Sans"/>
+                        </a:rPr>
+                        <a:t>Passes with a brief glance</a:t>
+                      </a:r>
+                      <a:endParaRPr sz="2000" b="0" dirty="0">
+                        <a:solidFill>
+                          <a:srgbClr val="26333C"/>
+                        </a:solidFill>
+                        <a:latin typeface="Noto Sans"/>
+                        <a:ea typeface="Noto Sans"/>
+                        <a:cs typeface="Noto Sans"/>
+                      </a:endParaRPr>
+                    </a:p>
+                  </a:txBody>
+                  <a:tcPr marL="95250" marR="95250" marT="66675" marB="66675" anchor="ctr">
+                    <a:solidFill>
+                      <a:srgbClr val="EEF5F7"/>
+                    </a:solidFill>
+                  </a:tcPr>
+                </a:tc>
+                <a:tc>
+                  <a:txBody>
+                    <a:bodyPr/>
+                    <a:lstStyle/>
+                    <a:p>
+                      <a:pPr algn="ctr"/>
+                      <a:r>
+                        <a:rPr lang="en-AU" sz="2325" b="0" dirty="0">
+                          <a:solidFill>
+                            <a:srgbClr val="26333C"/>
+                          </a:solidFill>
+                          <a:latin typeface="Noto Sans"/>
+                          <a:ea typeface="Noto Sans"/>
+                          <a:cs typeface="Noto Sans"/>
+                        </a:rPr>
+                        <a:t>CONTINUE (73.8%)</a:t>
+                      </a:r>
+                    </a:p>
+                  </a:txBody>
+                  <a:tcPr marL="95250" marR="95250" marT="66675" marB="66675" anchor="ctr">
+                    <a:solidFill>
+                      <a:srgbClr val="EEF5F7"/>
+                    </a:solidFill>
+                  </a:tcPr>
+                </a:tc>
+                <a:tc>
+                  <a:txBody>
+                    <a:bodyPr/>
+                    <a:lstStyle/>
+                    <a:p>
+                      <a:pPr algn="ctr"/>
+                      <a:r>
+                        <a:rPr sz="2325" b="0">
+                          <a:solidFill>
+                            <a:srgbClr val="26333C"/>
+                          </a:solidFill>
+                          <a:latin typeface="Noto Sans"/>
+                          <a:ea typeface="Noto Sans"/>
+                          <a:cs typeface="Noto Sans"/>
+                        </a:rPr>
+                        <a:t>[Action]</a:t>
+                      </a:r>
+                    </a:p>
+                  </a:txBody>
+                  <a:tcPr marL="95250" marR="95250" marT="66675" marB="66675" anchor="ctr">
+                    <a:solidFill>
+                      <a:srgbClr val="EEF5F7"/>
+                    </a:solidFill>
+                  </a:tcPr>
+                </a:tc>
+                <a:tc>
+                  <a:txBody>
+                    <a:bodyPr/>
+                    <a:lstStyle/>
+                    <a:p>
+                      <a:pPr algn="ctr"/>
+                      <a:r>
+                        <a:rPr sz="2325" b="0">
+                          <a:solidFill>
+                            <a:srgbClr val="26333C"/>
+                          </a:solidFill>
+                          <a:latin typeface="Noto Sans"/>
+                          <a:ea typeface="Noto Sans"/>
+                          <a:cs typeface="Noto Sans"/>
+                        </a:rPr>
+                        <a:t>[Action]</a:t>
+                      </a:r>
+                    </a:p>
+                  </a:txBody>
+                  <a:tcPr marL="95250" marR="95250" marT="66675" marB="66675" anchor="ctr">
+                    <a:solidFill>
+                      <a:srgbClr val="EEF5F7"/>
+                    </a:solidFill>
+                  </a:tcPr>
+                </a:tc>
+                <a:extLst>
+                  <a:ext uri="{0D108BD9-81ED-4DB2-BD59-A6C34878D82A}">
+                    <a16:rowId xmlns:a16="http://schemas.microsoft.com/office/drawing/2014/main" val="10006"/>
+                  </a:ext>
+                </a:extLst>
+              </a:tr>
+              <a:tr h="523875">
+                <a:tc>
+                  <a:txBody>
+                    <a:bodyPr/>
+                    <a:lstStyle/>
+                    <a:p>
+                      <a:pPr algn="l"/>
+                      <a:r>
+                        <a:rPr lang="en-AU" sz="2000" b="0" dirty="0">
+                          <a:solidFill>
+                            <a:srgbClr val="26333C"/>
+                          </a:solidFill>
+                          <a:latin typeface="Noto Sans"/>
+                          <a:ea typeface="Noto Sans"/>
+                          <a:cs typeface="Noto Sans"/>
+                        </a:rPr>
+                        <a:t>Beside route, intermittent gaze</a:t>
+                      </a:r>
+                    </a:p>
+                  </a:txBody>
+                  <a:tcPr marL="95250" marR="95250" marT="66675" marB="66675" anchor="ctr">
+                    <a:solidFill>
+                      <a:srgbClr val="FFFFFF"/>
+                    </a:solidFill>
+                  </a:tcPr>
+                </a:tc>
+                <a:tc>
+                  <a:txBody>
+                    <a:bodyPr/>
+                    <a:lstStyle/>
+                    <a:p>
+                      <a:pPr algn="ctr"/>
+                      <a:r>
+                        <a:rPr lang="en-AU" sz="2325" b="0" dirty="0">
+                          <a:solidFill>
+                            <a:srgbClr val="26333C"/>
+                          </a:solidFill>
+                          <a:latin typeface="Noto Sans"/>
+                          <a:ea typeface="Noto Sans"/>
+                          <a:cs typeface="Noto Sans"/>
+                        </a:rPr>
+                        <a:t>APPROACH (50.0%)</a:t>
+                      </a:r>
+                    </a:p>
+                  </a:txBody>
+                  <a:tcPr marL="95250" marR="95250" marT="66675" marB="66675" anchor="ctr">
+                    <a:solidFill>
+                      <a:srgbClr val="FFFFFF"/>
+                    </a:solidFill>
+                  </a:tcPr>
+                </a:tc>
+                <a:tc>
+                  <a:txBody>
+                    <a:bodyPr/>
+                    <a:lstStyle/>
+                    <a:p>
+                      <a:pPr algn="ctr"/>
+                      <a:r>
+                        <a:rPr sz="2325" b="0">
+                          <a:solidFill>
+                            <a:srgbClr val="26333C"/>
+                          </a:solidFill>
+                          <a:latin typeface="Noto Sans"/>
+                          <a:ea typeface="Noto Sans"/>
+                          <a:cs typeface="Noto Sans"/>
+                        </a:rPr>
+                        <a:t>[Action]</a:t>
+                      </a:r>
+                    </a:p>
+                  </a:txBody>
+                  <a:tcPr marL="95250" marR="95250" marT="66675" marB="66675" anchor="ctr">
+                    <a:solidFill>
+                      <a:srgbClr val="FFFFFF"/>
+                    </a:solidFill>
+                  </a:tcPr>
+                </a:tc>
+                <a:tc>
+                  <a:txBody>
+                    <a:bodyPr/>
+                    <a:lstStyle/>
+                    <a:p>
+                      <a:pPr algn="ctr"/>
+                      <a:r>
+                        <a:rPr sz="2325" b="0">
+                          <a:solidFill>
+                            <a:srgbClr val="26333C"/>
+                          </a:solidFill>
+                          <a:latin typeface="Noto Sans"/>
+                          <a:ea typeface="Noto Sans"/>
+                          <a:cs typeface="Noto Sans"/>
+                        </a:rPr>
+                        <a:t>[Action]</a:t>
+                      </a:r>
+                    </a:p>
+                  </a:txBody>
+                  <a:tcPr marL="95250" marR="95250" marT="66675" marB="66675" anchor="ctr">
+                    <a:solidFill>
+                      <a:srgbClr val="FFFFFF"/>
+                    </a:solidFill>
+                  </a:tcPr>
+                </a:tc>
+                <a:extLst>
+                  <a:ext uri="{0D108BD9-81ED-4DB2-BD59-A6C34878D82A}">
+                    <a16:rowId xmlns:a16="http://schemas.microsoft.com/office/drawing/2014/main" val="10007"/>
+                  </a:ext>
+                </a:extLst>
+              </a:tr>
+              <a:tr h="523875">
+                <a:tc>
+                  <a:txBody>
+                    <a:bodyPr/>
+                    <a:lstStyle/>
+                    <a:p>
+                      <a:pPr algn="l"/>
+                      <a:r>
+                        <a:rPr lang="en-AU" sz="2000" b="0" dirty="0">
+                          <a:solidFill>
+                            <a:srgbClr val="26333C"/>
+                          </a:solidFill>
+                          <a:latin typeface="Noto Sans"/>
+                          <a:ea typeface="Noto Sans"/>
+                          <a:cs typeface="Noto Sans"/>
+                        </a:rPr>
+                        <a:t>Walks away while looking</a:t>
+                      </a:r>
+                      <a:endParaRPr sz="2000" b="0" dirty="0">
+                        <a:solidFill>
+                          <a:srgbClr val="26333C"/>
+                        </a:solidFill>
+                        <a:latin typeface="Noto Sans"/>
+                        <a:ea typeface="Noto Sans"/>
+                        <a:cs typeface="Noto Sans"/>
+                      </a:endParaRPr>
+                    </a:p>
+                  </a:txBody>
+                  <a:tcPr marL="95250" marR="95250" marT="66675" marB="66675" anchor="ctr">
+                    <a:solidFill>
+                      <a:srgbClr val="EEF5F7"/>
+                    </a:solidFill>
+                  </a:tcPr>
+                </a:tc>
+                <a:tc>
+                  <a:txBody>
+                    <a:bodyPr/>
+                    <a:lstStyle/>
+                    <a:p>
+                      <a:pPr algn="ctr"/>
+                      <a:r>
+                        <a:rPr lang="en-AU" sz="2325" b="0" dirty="0">
+                          <a:solidFill>
+                            <a:srgbClr val="26333C"/>
+                          </a:solidFill>
+                          <a:latin typeface="Noto Sans"/>
+                          <a:ea typeface="Noto Sans"/>
+                          <a:cs typeface="Noto Sans"/>
+                        </a:rPr>
+                        <a:t>ENGAGE (61.9%)</a:t>
+                      </a:r>
+                    </a:p>
+                  </a:txBody>
+                  <a:tcPr marL="95250" marR="95250" marT="66675" marB="66675" anchor="ctr">
+                    <a:solidFill>
+                      <a:srgbClr val="EEF5F7"/>
+                    </a:solidFill>
+                  </a:tcPr>
+                </a:tc>
+                <a:tc>
+                  <a:txBody>
+                    <a:bodyPr/>
+                    <a:lstStyle/>
+                    <a:p>
+                      <a:pPr algn="ctr"/>
+                      <a:r>
+                        <a:rPr sz="2325" b="0">
+                          <a:solidFill>
+                            <a:srgbClr val="26333C"/>
+                          </a:solidFill>
+                          <a:latin typeface="Noto Sans"/>
+                          <a:ea typeface="Noto Sans"/>
+                          <a:cs typeface="Noto Sans"/>
+                        </a:rPr>
+                        <a:t>[Action]</a:t>
+                      </a:r>
+                    </a:p>
+                  </a:txBody>
+                  <a:tcPr marL="95250" marR="95250" marT="66675" marB="66675" anchor="ctr">
+                    <a:solidFill>
+                      <a:srgbClr val="EEF5F7"/>
+                    </a:solidFill>
+                  </a:tcPr>
+                </a:tc>
+                <a:tc>
+                  <a:txBody>
+                    <a:bodyPr/>
+                    <a:lstStyle/>
+                    <a:p>
+                      <a:pPr algn="ctr"/>
+                      <a:r>
+                        <a:rPr sz="2325" b="0" dirty="0">
+                          <a:solidFill>
+                            <a:srgbClr val="26333C"/>
+                          </a:solidFill>
+                          <a:latin typeface="Noto Sans"/>
+                          <a:ea typeface="Noto Sans"/>
+                          <a:cs typeface="Noto Sans"/>
+                        </a:rPr>
+                        <a:t>[Action]</a:t>
+                      </a:r>
+                    </a:p>
+                  </a:txBody>
+                  <a:tcPr marL="95250" marR="95250" marT="66675" marB="66675" anchor="ctr">
+                    <a:solidFill>
+                      <a:srgbClr val="EEF5F7"/>
+                    </a:solidFill>
+                  </a:tcPr>
+                </a:tc>
+                <a:extLst>
+                  <a:ext uri="{0D108BD9-81ED-4DB2-BD59-A6C34878D82A}">
+                    <a16:rowId xmlns:a16="http://schemas.microsoft.com/office/drawing/2014/main" val="10008"/>
+                  </a:ext>
+                </a:extLst>
+              </a:tr>
+            </a:tbl>
+          </a:graphicData>
+        </a:graphic>
+      </p:graphicFrame>
+      <p:sp>
+        <p:nvSpPr>
+          <p:cNvPr id="477" name="results-agreement-title">
+            <a:extLst>
+              <a:ext uri="{FF2B5EF4-FFF2-40B4-BE49-F238E27FC236}">
+                <a16:creationId xmlns:a16="http://schemas.microsoft.com/office/drawing/2014/main" id="{D89D25FA-4D2A-C559-9F72-E54C4F3791A5}"/>
+              </a:ext>
+            </a:extLst>
+          </p:cNvPr>
+          <p:cNvSpPr>
+            <a:spLocks noGrp="1"/>
+          </p:cNvSpPr>
+          <p:nvPr/>
+        </p:nvSpPr>
+        <p:spPr>
+          <a:xfrm>
+            <a:off x="1336675" y="23510875"/>
+            <a:ext cx="12096750" cy="428625"/>
+          </a:xfrm>
+          <a:prstGeom prst="rect">
+            <a:avLst/>
+          </a:prstGeom>
+          <a:noFill/>
+          <a:ln w="0">
+            <a:noFill/>
+          </a:ln>
+        </p:spPr>
+        <p:txBody>
+          <a:bodyPr wrap="square" lIns="0" tIns="0" rIns="0" bIns="0">
+            <a:noAutofit/>
+          </a:bodyPr>
+          <a:lstStyle>
+            <a:defPPr>
+              <a:defRPr sz="2700" b="1">
+                <a:solidFill>
+                  <a:srgbClr val="22577A"/>
+                </a:solidFill>
+                <a:latin typeface="Rubik"/>
+                <a:ea typeface="Rubik"/>
+                <a:cs typeface="Rubik"/>
+              </a:defRPr>
+            </a:defPPr>
+          </a:lstStyle>
+          <a:p>
+            <a:pPr>
+              <a:defRPr sz="2700" b="1">
+                <a:solidFill>
+                  <a:srgbClr val="22577A"/>
+                </a:solidFill>
+                <a:latin typeface="Rubik"/>
+                <a:ea typeface="Rubik"/>
+                <a:cs typeface="Rubik"/>
+              </a:defRPr>
+            </a:pPr>
+            <a:r>
+              <a:rPr sz="2700" b="1" dirty="0">
+                <a:solidFill>
+                  <a:srgbClr val="22577A"/>
+                </a:solidFill>
+                <a:latin typeface="Rubik"/>
+                <a:ea typeface="Rubik"/>
+                <a:cs typeface="Rubik"/>
+              </a:rPr>
+              <a:t>Agreement with survey preference</a:t>
+            </a:r>
+          </a:p>
+        </p:txBody>
+      </p:sp>
+      <p:sp>
+        <p:nvSpPr>
+          <p:cNvPr id="478" name="results-agreement-summary">
+            <a:extLst>
+              <a:ext uri="{FF2B5EF4-FFF2-40B4-BE49-F238E27FC236}">
+                <a16:creationId xmlns:a16="http://schemas.microsoft.com/office/drawing/2014/main" id="{B3E784F0-6F62-7CCA-D782-D2C929717C09}"/>
+              </a:ext>
+            </a:extLst>
+          </p:cNvPr>
+          <p:cNvSpPr>
+            <a:spLocks noGrp="1"/>
+          </p:cNvSpPr>
+          <p:nvPr/>
+        </p:nvSpPr>
+        <p:spPr>
+          <a:xfrm>
+            <a:off x="1336675" y="23939500"/>
+            <a:ext cx="12096750" cy="409575"/>
+          </a:xfrm>
+          <a:prstGeom prst="rect">
+            <a:avLst/>
+          </a:prstGeom>
+          <a:noFill/>
+          <a:ln w="0">
+            <a:noFill/>
+          </a:ln>
+        </p:spPr>
+        <p:txBody>
+          <a:bodyPr wrap="square" lIns="0" tIns="0" rIns="0" bIns="0">
+            <a:noAutofit/>
+          </a:bodyPr>
+          <a:lstStyle>
+            <a:defPPr>
+              <a:defRPr sz="2625" b="0">
+                <a:solidFill>
+                  <a:srgbClr val="26333C"/>
+                </a:solidFill>
+                <a:latin typeface="Noto Sans"/>
+                <a:ea typeface="Noto Sans"/>
+                <a:cs typeface="Noto Sans"/>
+              </a:defRPr>
+            </a:defPPr>
+          </a:lstStyle>
+          <a:p>
+            <a:pPr>
+              <a:defRPr sz="2625" b="0">
+                <a:solidFill>
+                  <a:srgbClr val="26333C"/>
+                </a:solidFill>
+                <a:latin typeface="Noto Sans"/>
+                <a:ea typeface="Noto Sans"/>
+                <a:cs typeface="Noto Sans"/>
+              </a:defRPr>
+            </a:pPr>
+            <a:r>
+              <a:rPr sz="2625" b="0" dirty="0">
+                <a:solidFill>
+                  <a:srgbClr val="26333C"/>
+                </a:solidFill>
+                <a:latin typeface="Noto Sans"/>
+                <a:ea typeface="Noto Sans"/>
+                <a:cs typeface="Noto Sans"/>
+              </a:rPr>
+              <a:t>Rule-based [X]/8     LLM [Y]/8</a:t>
+            </a:r>
+          </a:p>
+        </p:txBody>
+      </p:sp>
+      <p:sp>
+        <p:nvSpPr>
+          <p:cNvPr id="479" name="results-survey-metadata">
+            <a:extLst>
+              <a:ext uri="{FF2B5EF4-FFF2-40B4-BE49-F238E27FC236}">
+                <a16:creationId xmlns:a16="http://schemas.microsoft.com/office/drawing/2014/main" id="{D0D74C3C-62A5-73EA-AC3B-2A91628C4AAB}"/>
+              </a:ext>
+            </a:extLst>
+          </p:cNvPr>
+          <p:cNvSpPr>
+            <a:spLocks noGrp="1"/>
+          </p:cNvSpPr>
+          <p:nvPr/>
+        </p:nvSpPr>
+        <p:spPr>
+          <a:xfrm>
+            <a:off x="6184535" y="23978749"/>
+            <a:ext cx="12096750" cy="342900"/>
+          </a:xfrm>
+          <a:prstGeom prst="rect">
+            <a:avLst/>
+          </a:prstGeom>
+          <a:noFill/>
+          <a:ln w="0">
+            <a:noFill/>
+          </a:ln>
+        </p:spPr>
+        <p:txBody>
+          <a:bodyPr wrap="square" lIns="0" tIns="0" rIns="0" bIns="0">
+            <a:noAutofit/>
+          </a:bodyPr>
+          <a:lstStyle>
+            <a:defPPr>
+              <a:defRPr sz="1800" b="0">
+                <a:solidFill>
+                  <a:srgbClr val="26333C"/>
+                </a:solidFill>
+                <a:latin typeface="Noto Sans"/>
+                <a:ea typeface="Noto Sans"/>
+                <a:cs typeface="Noto Sans"/>
+              </a:defRPr>
+            </a:defPPr>
+          </a:lstStyle>
+          <a:p>
+            <a:pPr>
+              <a:defRPr sz="1800" b="0">
+                <a:solidFill>
+                  <a:srgbClr val="26333C"/>
+                </a:solidFill>
+                <a:latin typeface="Noto Sans"/>
+                <a:ea typeface="Noto Sans"/>
+                <a:cs typeface="Noto Sans"/>
+              </a:defRPr>
+            </a:pPr>
+            <a:r>
+              <a:rPr sz="1800" b="0" dirty="0">
+                <a:solidFill>
+                  <a:srgbClr val="26333C"/>
+                </a:solidFill>
+                <a:latin typeface="Noto Sans"/>
+                <a:ea typeface="Noto Sans"/>
+                <a:cs typeface="Noto Sans"/>
+              </a:rPr>
+              <a:t>N = </a:t>
+            </a:r>
+            <a:r>
+              <a:rPr lang="en-US" altLang="ko-KR" dirty="0">
+                <a:solidFill>
+                  <a:srgbClr val="26333C"/>
+                </a:solidFill>
+                <a:latin typeface="Noto Sans"/>
+                <a:ea typeface="Noto Sans"/>
+                <a:cs typeface="Noto Sans"/>
+              </a:rPr>
+              <a:t>42</a:t>
+            </a:r>
+            <a:r>
+              <a:rPr lang="ko-KR" altLang="en-US" dirty="0">
+                <a:solidFill>
+                  <a:srgbClr val="26333C"/>
+                </a:solidFill>
+                <a:latin typeface="Noto Sans"/>
+                <a:ea typeface="Noto Sans"/>
+                <a:cs typeface="Noto Sans"/>
+              </a:rPr>
+              <a:t> </a:t>
+            </a:r>
+            <a:r>
+              <a:rPr sz="1800" b="0" dirty="0">
+                <a:solidFill>
+                  <a:srgbClr val="26333C"/>
+                </a:solidFill>
+                <a:latin typeface="Noto Sans"/>
+                <a:ea typeface="Noto Sans"/>
+                <a:cs typeface="Noto Sans"/>
+              </a:rPr>
+              <a:t>·  Eight selected scenarios  ·  Same decision point</a:t>
+            </a:r>
+          </a:p>
+        </p:txBody>
+      </p:sp>
+      <p:graphicFrame>
+        <p:nvGraphicFramePr>
+          <p:cNvPr id="480" name="Chart">
+            <a:extLst>
+              <a:ext uri="{FF2B5EF4-FFF2-40B4-BE49-F238E27FC236}">
+                <a16:creationId xmlns:a16="http://schemas.microsoft.com/office/drawing/2014/main" id="{C13C7F35-025F-88A7-FB9B-D5AB434A711B}"/>
+              </a:ext>
+            </a:extLst>
+          </p:cNvPr>
+          <p:cNvGraphicFramePr/>
+          <p:nvPr>
+            <p:extLst>
+              <p:ext uri="{D42A27DB-BD31-4B8C-83A1-F6EECF244321}">
+                <p14:modId xmlns:p14="http://schemas.microsoft.com/office/powerpoint/2010/main" val="2217779770"/>
+              </p:ext>
+            </p:extLst>
+          </p:nvPr>
+        </p:nvGraphicFramePr>
+        <p:xfrm>
+          <a:off x="13957300" y="17691100"/>
+          <a:ext cx="6096000" cy="5048250"/>
+        </p:xfrm>
+        <a:graphic>
+          <a:graphicData uri="http://schemas.openxmlformats.org/drawingml/2006/chart">
+            <c:chart xmlns:c="http://schemas.openxmlformats.org/drawingml/2006/chart" xmlns:r="http://schemas.openxmlformats.org/officeDocument/2006/relationships" r:id="rId7"/>
+          </a:graphicData>
+        </a:graphic>
+      </p:graphicFrame>
+      <p:sp>
+        <p:nvSpPr>
+          <p:cNvPr id="481" name="latency-means">
+            <a:extLst>
+              <a:ext uri="{FF2B5EF4-FFF2-40B4-BE49-F238E27FC236}">
+                <a16:creationId xmlns:a16="http://schemas.microsoft.com/office/drawing/2014/main" id="{1D18C6EE-9F6A-0458-55EC-F66D8CC267B2}"/>
+              </a:ext>
+            </a:extLst>
+          </p:cNvPr>
+          <p:cNvSpPr>
+            <a:spLocks noGrp="1"/>
+          </p:cNvSpPr>
+          <p:nvPr/>
+        </p:nvSpPr>
+        <p:spPr>
+          <a:xfrm>
+            <a:off x="13957300" y="22844125"/>
+            <a:ext cx="6096000" cy="400050"/>
+          </a:xfrm>
+          <a:prstGeom prst="rect">
+            <a:avLst/>
+          </a:prstGeom>
+          <a:noFill/>
+          <a:ln w="0">
+            <a:noFill/>
+          </a:ln>
+        </p:spPr>
+        <p:txBody>
+          <a:bodyPr wrap="square" lIns="0" tIns="0" rIns="0" bIns="0">
+            <a:noAutofit/>
+          </a:bodyPr>
+          <a:lstStyle>
+            <a:defPPr>
+              <a:defRPr sz="2025" b="0">
+                <a:solidFill>
+                  <a:srgbClr val="26333C"/>
+                </a:solidFill>
+                <a:latin typeface="Noto Sans"/>
+                <a:ea typeface="Noto Sans"/>
+                <a:cs typeface="Noto Sans"/>
+              </a:defRPr>
+            </a:defPPr>
+          </a:lstStyle>
+          <a:p>
+            <a:pPr>
+              <a:defRPr sz="2025" b="0">
+                <a:solidFill>
+                  <a:srgbClr val="26333C"/>
+                </a:solidFill>
+                <a:latin typeface="Noto Sans"/>
+                <a:ea typeface="Noto Sans"/>
+                <a:cs typeface="Noto Sans"/>
+              </a:defRPr>
+            </a:pPr>
+            <a:r>
+              <a:rPr sz="2025" b="0">
+                <a:solidFill>
+                  <a:srgbClr val="26333C"/>
+                </a:solidFill>
+                <a:latin typeface="Noto Sans"/>
+                <a:ea typeface="Noto Sans"/>
+                <a:cs typeface="Noto Sans"/>
+              </a:rPr>
+              <a:t>Rule-based [mean] s  ·  LLM [mean] s</a:t>
+            </a:r>
+          </a:p>
+        </p:txBody>
+      </p:sp>
+      <p:sp>
+        <p:nvSpPr>
+          <p:cNvPr id="482" name="latency-measurement-caption">
+            <a:extLst>
+              <a:ext uri="{FF2B5EF4-FFF2-40B4-BE49-F238E27FC236}">
+                <a16:creationId xmlns:a16="http://schemas.microsoft.com/office/drawing/2014/main" id="{8156AD54-DB0E-16B1-FD82-DDE76D009483}"/>
+              </a:ext>
+            </a:extLst>
+          </p:cNvPr>
+          <p:cNvSpPr>
+            <a:spLocks noGrp="1"/>
+          </p:cNvSpPr>
+          <p:nvPr/>
+        </p:nvSpPr>
+        <p:spPr>
+          <a:xfrm>
+            <a:off x="13957300" y="23320375"/>
+            <a:ext cx="6096000" cy="1190625"/>
+          </a:xfrm>
+          <a:prstGeom prst="rect">
+            <a:avLst/>
+          </a:prstGeom>
+          <a:noFill/>
+          <a:ln w="0">
+            <a:noFill/>
+          </a:ln>
+        </p:spPr>
+        <p:txBody>
+          <a:bodyPr wrap="square" lIns="0" tIns="0" rIns="0" bIns="0">
+            <a:noAutofit/>
+          </a:bodyPr>
+          <a:lstStyle>
+            <a:defPPr>
+              <a:defRPr sz="1875" b="0">
+                <a:solidFill>
+                  <a:srgbClr val="26333C"/>
+                </a:solidFill>
+                <a:latin typeface="Noto Sans"/>
+                <a:ea typeface="Noto Sans"/>
+                <a:cs typeface="Noto Sans"/>
+              </a:defRPr>
+            </a:defPPr>
+          </a:lstStyle>
+          <a:p>
+            <a:pPr>
+              <a:defRPr sz="1875" b="0">
+                <a:solidFill>
+                  <a:srgbClr val="26333C"/>
+                </a:solidFill>
+                <a:latin typeface="Noto Sans"/>
+                <a:ea typeface="Noto Sans"/>
+                <a:cs typeface="Noto Sans"/>
+              </a:defRPr>
+            </a:pPr>
+            <a:r>
+              <a:rPr sz="1875" b="0">
+                <a:solidFill>
+                  <a:srgbClr val="26333C"/>
+                </a:solidFill>
+                <a:latin typeface="Noto Sans"/>
+                <a:ea typeface="Noto Sans"/>
+                <a:cs typeface="Noto Sans"/>
+              </a:rPr>
+              <a:t>Same recorded inputs and hardware.</a:t>
+            </a:r>
+          </a:p>
+          <a:p>
+            <a:pPr>
+              <a:defRPr sz="1875" b="0">
+                <a:solidFill>
+                  <a:srgbClr val="26333C"/>
+                </a:solidFill>
+                <a:latin typeface="Noto Sans"/>
+                <a:ea typeface="Noto Sans"/>
+                <a:cs typeface="Noto Sans"/>
+              </a:defRPr>
+            </a:pPr>
+            <a:r>
+              <a:rPr sz="1875" b="0">
+                <a:solidFill>
+                  <a:srgbClr val="26333C"/>
+                </a:solidFill>
+                <a:latin typeface="Noto Sans"/>
+                <a:ea typeface="Noto Sans"/>
+                <a:cs typeface="Noto Sans"/>
+              </a:rPr>
+              <a:t>Decision request to returned action.</a:t>
+            </a:r>
+          </a:p>
+          <a:p>
+            <a:pPr>
+              <a:defRPr sz="1875" b="0">
+                <a:solidFill>
+                  <a:srgbClr val="26333C"/>
+                </a:solidFill>
+                <a:latin typeface="Noto Sans"/>
+                <a:ea typeface="Noto Sans"/>
+                <a:cs typeface="Noto Sans"/>
+              </a:defRPr>
+            </a:pPr>
+            <a:r>
+              <a:rPr sz="1875" b="0">
+                <a:solidFill>
+                  <a:srgbClr val="26333C"/>
+                </a:solidFill>
+                <a:latin typeface="Noto Sans"/>
+                <a:ea typeface="Noto Sans"/>
+                <a:cs typeface="Noto Sans"/>
+              </a:rPr>
+              <a:t>[Runs] repetitions; LLM: [model].</a:t>
+            </a:r>
           </a:p>
         </p:txBody>
       </p:sp>

</xml_diff>